<commit_message>
Conjugador: uitgebreid naar 325 werkwoorden (motor-database, presente nagerekend via motor-engine) + free-text vervoeging voor élk getypt werkwoord (regelmatig-fallback met waarschuwing); PowerPoint herbouwd met «verschijnen bij klik»-animaties (geen kiosk, 37 on-click onthullingen/deck, oplossingen in spreker-notities)
</commit_message>
<xml_diff>
--- a/03-build/pptx/C5_U0_alumno.pptx
+++ b/03-build/pptx/C5_U0_alumno.pptx
@@ -123,10 +123,6 @@
       </a:defRPr>
     </a:lvl9pPr>
   </p:defaultTextStyle>
-  <p:showPr showAnimation="1" useTimings="0" loop="0">
-    <p:kiosk/>
-    <p:sldAll/>
-  </p:showPr>
 </p:presentation>
 </file>
 
@@ -4229,7 +4225,7 @@
                 </a:solidFill>
                 <a:latin typeface="Inter"/>
               </a:rPr>
-              <a:t>Leerlingenversie — kioskmodus</a:t>
+              <a:t>Leerlingenversie — klik onthult</a:t>
             </a:r>
           </a:p>
         </p:txBody>
@@ -5612,7 +5608,7 @@
                 </a:solidFill>
                 <a:latin typeface="Inter"/>
               </a:rPr>
-              <a:t>Leerlingenversie — kioskmodus</a:t>
+              <a:t>Leerlingenversie — klik onthult</a:t>
             </a:r>
           </a:p>
         </p:txBody>
@@ -8621,7 +8617,7 @@
                 </a:solidFill>
                 <a:latin typeface="Inter"/>
               </a:rPr>
-              <a:t>Leerlingenversie — kioskmodus</a:t>
+              <a:t>Leerlingenversie — klik onthult</a:t>
             </a:r>
           </a:p>
         </p:txBody>
@@ -11117,7 +11113,7 @@
                 </a:solidFill>
                 <a:latin typeface="Inter"/>
               </a:rPr>
-              <a:t>Leerlingenversie — kioskmodus</a:t>
+              <a:t>Leerlingenversie — klik onthult</a:t>
             </a:r>
           </a:p>
         </p:txBody>
@@ -11179,7 +11175,432 @@
           <p:childTnLst>
             <p:seq concurrent="1" nextAc="seek">
               <p:cTn id="2" dur="indefinite" nodeType="mainSeq">
-                <p:childTnLst/>
+                <p:childTnLst>
+                  <p:par>
+                    <p:cTn id="3" fill="hold">
+                      <p:stCondLst>
+                        <p:cond delay="indefinite"/>
+                      </p:stCondLst>
+                      <p:childTnLst>
+                        <p:par>
+                          <p:cTn id="4" fill="hold">
+                            <p:stCondLst>
+                              <p:cond delay="0"/>
+                            </p:stCondLst>
+                            <p:childTnLst>
+                              <p:par>
+                                <p:cTn id="5" presetID="10" presetClass="entr" presetSubtype="0" fill="hold" grpId="0" nodeType="clickEffect">
+                                  <p:stCondLst>
+                                    <p:cond delay="0"/>
+                                  </p:stCondLst>
+                                  <p:childTnLst>
+                                    <p:set>
+                                      <p:cBhvr>
+                                        <p:cTn id="6" dur="1" fill="hold">
+                                          <p:stCondLst>
+                                            <p:cond delay="0"/>
+                                          </p:stCondLst>
+                                        </p:cTn>
+                                        <p:tgtEl>
+                                          <p:spTgt spid="12"/>
+                                        </p:tgtEl>
+                                        <p:attrNameLst>
+                                          <p:attrName>style.visibility</p:attrName>
+                                        </p:attrNameLst>
+                                      </p:cBhvr>
+                                      <p:to>
+                                        <p:strVal val="visible"/>
+                                      </p:to>
+                                    </p:set>
+                                    <p:animEffect transition="in" filter="fade">
+                                      <p:cBhvr>
+                                        <p:cTn id="7" dur="500"/>
+                                        <p:tgtEl>
+                                          <p:spTgt spid="12"/>
+                                        </p:tgtEl>
+                                      </p:cBhvr>
+                                    </p:animEffect>
+                                  </p:childTnLst>
+                                </p:cTn>
+                              </p:par>
+                            </p:childTnLst>
+                          </p:cTn>
+                        </p:par>
+                      </p:childTnLst>
+                    </p:cTn>
+                  </p:par>
+                  <p:par>
+                    <p:cTn id="8" fill="hold">
+                      <p:stCondLst>
+                        <p:cond delay="indefinite"/>
+                      </p:stCondLst>
+                      <p:childTnLst>
+                        <p:par>
+                          <p:cTn id="9" fill="hold">
+                            <p:stCondLst>
+                              <p:cond delay="0"/>
+                            </p:stCondLst>
+                            <p:childTnLst>
+                              <p:par>
+                                <p:cTn id="10" presetID="10" presetClass="entr" presetSubtype="0" fill="hold" grpId="0" nodeType="clickEffect">
+                                  <p:stCondLst>
+                                    <p:cond delay="0"/>
+                                  </p:stCondLst>
+                                  <p:childTnLst>
+                                    <p:set>
+                                      <p:cBhvr>
+                                        <p:cTn id="11" dur="1" fill="hold">
+                                          <p:stCondLst>
+                                            <p:cond delay="0"/>
+                                          </p:stCondLst>
+                                        </p:cTn>
+                                        <p:tgtEl>
+                                          <p:spTgt spid="17"/>
+                                        </p:tgtEl>
+                                        <p:attrNameLst>
+                                          <p:attrName>style.visibility</p:attrName>
+                                        </p:attrNameLst>
+                                      </p:cBhvr>
+                                      <p:to>
+                                        <p:strVal val="visible"/>
+                                      </p:to>
+                                    </p:set>
+                                    <p:animEffect transition="in" filter="fade">
+                                      <p:cBhvr>
+                                        <p:cTn id="12" dur="500"/>
+                                        <p:tgtEl>
+                                          <p:spTgt spid="17"/>
+                                        </p:tgtEl>
+                                      </p:cBhvr>
+                                    </p:animEffect>
+                                  </p:childTnLst>
+                                </p:cTn>
+                              </p:par>
+                            </p:childTnLst>
+                          </p:cTn>
+                        </p:par>
+                      </p:childTnLst>
+                    </p:cTn>
+                  </p:par>
+                  <p:par>
+                    <p:cTn id="13" fill="hold">
+                      <p:stCondLst>
+                        <p:cond delay="indefinite"/>
+                      </p:stCondLst>
+                      <p:childTnLst>
+                        <p:par>
+                          <p:cTn id="14" fill="hold">
+                            <p:stCondLst>
+                              <p:cond delay="0"/>
+                            </p:stCondLst>
+                            <p:childTnLst>
+                              <p:par>
+                                <p:cTn id="15" presetID="10" presetClass="entr" presetSubtype="0" fill="hold" grpId="0" nodeType="clickEffect">
+                                  <p:stCondLst>
+                                    <p:cond delay="0"/>
+                                  </p:stCondLst>
+                                  <p:childTnLst>
+                                    <p:set>
+                                      <p:cBhvr>
+                                        <p:cTn id="16" dur="1" fill="hold">
+                                          <p:stCondLst>
+                                            <p:cond delay="0"/>
+                                          </p:stCondLst>
+                                        </p:cTn>
+                                        <p:tgtEl>
+                                          <p:spTgt spid="22"/>
+                                        </p:tgtEl>
+                                        <p:attrNameLst>
+                                          <p:attrName>style.visibility</p:attrName>
+                                        </p:attrNameLst>
+                                      </p:cBhvr>
+                                      <p:to>
+                                        <p:strVal val="visible"/>
+                                      </p:to>
+                                    </p:set>
+                                    <p:animEffect transition="in" filter="fade">
+                                      <p:cBhvr>
+                                        <p:cTn id="17" dur="500"/>
+                                        <p:tgtEl>
+                                          <p:spTgt spid="22"/>
+                                        </p:tgtEl>
+                                      </p:cBhvr>
+                                    </p:animEffect>
+                                  </p:childTnLst>
+                                </p:cTn>
+                              </p:par>
+                            </p:childTnLst>
+                          </p:cTn>
+                        </p:par>
+                      </p:childTnLst>
+                    </p:cTn>
+                  </p:par>
+                  <p:par>
+                    <p:cTn id="18" fill="hold">
+                      <p:stCondLst>
+                        <p:cond delay="indefinite"/>
+                      </p:stCondLst>
+                      <p:childTnLst>
+                        <p:par>
+                          <p:cTn id="19" fill="hold">
+                            <p:stCondLst>
+                              <p:cond delay="0"/>
+                            </p:stCondLst>
+                            <p:childTnLst>
+                              <p:par>
+                                <p:cTn id="20" presetID="10" presetClass="entr" presetSubtype="0" fill="hold" grpId="0" nodeType="clickEffect">
+                                  <p:stCondLst>
+                                    <p:cond delay="0"/>
+                                  </p:stCondLst>
+                                  <p:childTnLst>
+                                    <p:set>
+                                      <p:cBhvr>
+                                        <p:cTn id="21" dur="1" fill="hold">
+                                          <p:stCondLst>
+                                            <p:cond delay="0"/>
+                                          </p:stCondLst>
+                                        </p:cTn>
+                                        <p:tgtEl>
+                                          <p:spTgt spid="27"/>
+                                        </p:tgtEl>
+                                        <p:attrNameLst>
+                                          <p:attrName>style.visibility</p:attrName>
+                                        </p:attrNameLst>
+                                      </p:cBhvr>
+                                      <p:to>
+                                        <p:strVal val="visible"/>
+                                      </p:to>
+                                    </p:set>
+                                    <p:animEffect transition="in" filter="fade">
+                                      <p:cBhvr>
+                                        <p:cTn id="22" dur="500"/>
+                                        <p:tgtEl>
+                                          <p:spTgt spid="27"/>
+                                        </p:tgtEl>
+                                      </p:cBhvr>
+                                    </p:animEffect>
+                                  </p:childTnLst>
+                                </p:cTn>
+                              </p:par>
+                            </p:childTnLst>
+                          </p:cTn>
+                        </p:par>
+                      </p:childTnLst>
+                    </p:cTn>
+                  </p:par>
+                  <p:par>
+                    <p:cTn id="23" fill="hold">
+                      <p:stCondLst>
+                        <p:cond delay="indefinite"/>
+                      </p:stCondLst>
+                      <p:childTnLst>
+                        <p:par>
+                          <p:cTn id="24" fill="hold">
+                            <p:stCondLst>
+                              <p:cond delay="0"/>
+                            </p:stCondLst>
+                            <p:childTnLst>
+                              <p:par>
+                                <p:cTn id="25" presetID="10" presetClass="entr" presetSubtype="0" fill="hold" grpId="0" nodeType="clickEffect">
+                                  <p:stCondLst>
+                                    <p:cond delay="0"/>
+                                  </p:stCondLst>
+                                  <p:childTnLst>
+                                    <p:set>
+                                      <p:cBhvr>
+                                        <p:cTn id="26" dur="1" fill="hold">
+                                          <p:stCondLst>
+                                            <p:cond delay="0"/>
+                                          </p:stCondLst>
+                                        </p:cTn>
+                                        <p:tgtEl>
+                                          <p:spTgt spid="32"/>
+                                        </p:tgtEl>
+                                        <p:attrNameLst>
+                                          <p:attrName>style.visibility</p:attrName>
+                                        </p:attrNameLst>
+                                      </p:cBhvr>
+                                      <p:to>
+                                        <p:strVal val="visible"/>
+                                      </p:to>
+                                    </p:set>
+                                    <p:animEffect transition="in" filter="fade">
+                                      <p:cBhvr>
+                                        <p:cTn id="27" dur="500"/>
+                                        <p:tgtEl>
+                                          <p:spTgt spid="32"/>
+                                        </p:tgtEl>
+                                      </p:cBhvr>
+                                    </p:animEffect>
+                                  </p:childTnLst>
+                                </p:cTn>
+                              </p:par>
+                            </p:childTnLst>
+                          </p:cTn>
+                        </p:par>
+                      </p:childTnLst>
+                    </p:cTn>
+                  </p:par>
+                  <p:par>
+                    <p:cTn id="28" fill="hold">
+                      <p:stCondLst>
+                        <p:cond delay="indefinite"/>
+                      </p:stCondLst>
+                      <p:childTnLst>
+                        <p:par>
+                          <p:cTn id="29" fill="hold">
+                            <p:stCondLst>
+                              <p:cond delay="0"/>
+                            </p:stCondLst>
+                            <p:childTnLst>
+                              <p:par>
+                                <p:cTn id="30" presetID="10" presetClass="entr" presetSubtype="0" fill="hold" grpId="0" nodeType="clickEffect">
+                                  <p:stCondLst>
+                                    <p:cond delay="0"/>
+                                  </p:stCondLst>
+                                  <p:childTnLst>
+                                    <p:set>
+                                      <p:cBhvr>
+                                        <p:cTn id="31" dur="1" fill="hold">
+                                          <p:stCondLst>
+                                            <p:cond delay="0"/>
+                                          </p:stCondLst>
+                                        </p:cTn>
+                                        <p:tgtEl>
+                                          <p:spTgt spid="37"/>
+                                        </p:tgtEl>
+                                        <p:attrNameLst>
+                                          <p:attrName>style.visibility</p:attrName>
+                                        </p:attrNameLst>
+                                      </p:cBhvr>
+                                      <p:to>
+                                        <p:strVal val="visible"/>
+                                      </p:to>
+                                    </p:set>
+                                    <p:animEffect transition="in" filter="fade">
+                                      <p:cBhvr>
+                                        <p:cTn id="32" dur="500"/>
+                                        <p:tgtEl>
+                                          <p:spTgt spid="37"/>
+                                        </p:tgtEl>
+                                      </p:cBhvr>
+                                    </p:animEffect>
+                                  </p:childTnLst>
+                                </p:cTn>
+                              </p:par>
+                            </p:childTnLst>
+                          </p:cTn>
+                        </p:par>
+                      </p:childTnLst>
+                    </p:cTn>
+                  </p:par>
+                  <p:par>
+                    <p:cTn id="33" fill="hold">
+                      <p:stCondLst>
+                        <p:cond delay="indefinite"/>
+                      </p:stCondLst>
+                      <p:childTnLst>
+                        <p:par>
+                          <p:cTn id="34" fill="hold">
+                            <p:stCondLst>
+                              <p:cond delay="0"/>
+                            </p:stCondLst>
+                            <p:childTnLst>
+                              <p:par>
+                                <p:cTn id="35" presetID="10" presetClass="entr" presetSubtype="0" fill="hold" grpId="0" nodeType="clickEffect">
+                                  <p:stCondLst>
+                                    <p:cond delay="0"/>
+                                  </p:stCondLst>
+                                  <p:childTnLst>
+                                    <p:set>
+                                      <p:cBhvr>
+                                        <p:cTn id="36" dur="1" fill="hold">
+                                          <p:stCondLst>
+                                            <p:cond delay="0"/>
+                                          </p:stCondLst>
+                                        </p:cTn>
+                                        <p:tgtEl>
+                                          <p:spTgt spid="42"/>
+                                        </p:tgtEl>
+                                        <p:attrNameLst>
+                                          <p:attrName>style.visibility</p:attrName>
+                                        </p:attrNameLst>
+                                      </p:cBhvr>
+                                      <p:to>
+                                        <p:strVal val="visible"/>
+                                      </p:to>
+                                    </p:set>
+                                    <p:animEffect transition="in" filter="fade">
+                                      <p:cBhvr>
+                                        <p:cTn id="37" dur="500"/>
+                                        <p:tgtEl>
+                                          <p:spTgt spid="42"/>
+                                        </p:tgtEl>
+                                      </p:cBhvr>
+                                    </p:animEffect>
+                                  </p:childTnLst>
+                                </p:cTn>
+                              </p:par>
+                            </p:childTnLst>
+                          </p:cTn>
+                        </p:par>
+                      </p:childTnLst>
+                    </p:cTn>
+                  </p:par>
+                  <p:par>
+                    <p:cTn id="38" fill="hold">
+                      <p:stCondLst>
+                        <p:cond delay="indefinite"/>
+                      </p:stCondLst>
+                      <p:childTnLst>
+                        <p:par>
+                          <p:cTn id="39" fill="hold">
+                            <p:stCondLst>
+                              <p:cond delay="0"/>
+                            </p:stCondLst>
+                            <p:childTnLst>
+                              <p:par>
+                                <p:cTn id="40" presetID="10" presetClass="entr" presetSubtype="0" fill="hold" grpId="0" nodeType="clickEffect">
+                                  <p:stCondLst>
+                                    <p:cond delay="0"/>
+                                  </p:stCondLst>
+                                  <p:childTnLst>
+                                    <p:set>
+                                      <p:cBhvr>
+                                        <p:cTn id="41" dur="1" fill="hold">
+                                          <p:stCondLst>
+                                            <p:cond delay="0"/>
+                                          </p:stCondLst>
+                                        </p:cTn>
+                                        <p:tgtEl>
+                                          <p:spTgt spid="43"/>
+                                        </p:tgtEl>
+                                        <p:attrNameLst>
+                                          <p:attrName>style.visibility</p:attrName>
+                                        </p:attrNameLst>
+                                      </p:cBhvr>
+                                      <p:to>
+                                        <p:strVal val="visible"/>
+                                      </p:to>
+                                    </p:set>
+                                    <p:animEffect transition="in" filter="fade">
+                                      <p:cBhvr>
+                                        <p:cTn id="42" dur="500"/>
+                                        <p:tgtEl>
+                                          <p:spTgt spid="43"/>
+                                        </p:tgtEl>
+                                      </p:cBhvr>
+                                    </p:animEffect>
+                                  </p:childTnLst>
+                                </p:cTn>
+                              </p:par>
+                            </p:childTnLst>
+                          </p:cTn>
+                        </p:par>
+                      </p:childTnLst>
+                    </p:cTn>
+                  </p:par>
+                </p:childTnLst>
               </p:cTn>
               <p:prevCondLst>
                 <p:cond evt="onPrev" delay="0">
@@ -11192,542 +11613,6 @@
                 <p:cond evt="onNext" delay="0">
                   <p:tgtEl>
                     <p:sldTgt/>
-                  </p:tgtEl>
-                </p:cond>
-              </p:nextCondLst>
-            </p:seq>
-            <p:seq concurrent="1" nextAc="seek">
-              <p:cTn id="5" restart="whenNotActive" fill="hold" nodeType="interactiveSeq">
-                <p:stCondLst>
-                  <p:cond evt="onClick" delay="0">
-                    <p:tgtEl>
-                      <p:spTgt spid="8"/>
-                    </p:tgtEl>
-                  </p:cond>
-                </p:stCondLst>
-                <p:endSync evt="end" delay="0">
-                  <p:rtn val="all"/>
-                </p:endSync>
-                <p:childTnLst>
-                  <p:par>
-                    <p:cTn id="6" fill="hold">
-                      <p:stCondLst>
-                        <p:cond delay="0"/>
-                      </p:stCondLst>
-                      <p:childTnLst>
-                        <p:par>
-                          <p:cTn id="7" presetID="10" presetClass="entr" presetSubtype="0" fill="hold" grpId="0" nodeType="clickEffect">
-                            <p:stCondLst>
-                              <p:cond delay="0"/>
-                            </p:stCondLst>
-                            <p:childTnLst>
-                              <p:set>
-                                <p:cBhvr>
-                                  <p:cTn id="8" dur="1" fill="hold">
-                                    <p:stCondLst>
-                                      <p:cond delay="0"/>
-                                    </p:stCondLst>
-                                  </p:cTn>
-                                  <p:tgtEl>
-                                    <p:spTgt spid="12"/>
-                                  </p:tgtEl>
-                                  <p:attrNameLst>
-                                    <p:attrName>style.visibility</p:attrName>
-                                  </p:attrNameLst>
-                                </p:cBhvr>
-                                <p:to>
-                                  <p:strVal val="visible"/>
-                                </p:to>
-                              </p:set>
-                              <p:animEffect transition="in" filter="fade">
-                                <p:cBhvr>
-                                  <p:cTn id="9" dur="400"/>
-                                  <p:tgtEl>
-                                    <p:spTgt spid="12"/>
-                                  </p:tgtEl>
-                                </p:cBhvr>
-                              </p:animEffect>
-                            </p:childTnLst>
-                          </p:cTn>
-                        </p:par>
-                      </p:childTnLst>
-                    </p:cTn>
-                  </p:par>
-                </p:childTnLst>
-              </p:cTn>
-              <p:nextCondLst>
-                <p:cond evt="onClick" delay="0">
-                  <p:tgtEl>
-                    <p:spTgt spid="8"/>
-                  </p:tgtEl>
-                </p:cond>
-              </p:nextCondLst>
-            </p:seq>
-            <p:seq concurrent="1" nextAc="seek">
-              <p:cTn id="15" restart="whenNotActive" fill="hold" nodeType="interactiveSeq">
-                <p:stCondLst>
-                  <p:cond evt="onClick" delay="0">
-                    <p:tgtEl>
-                      <p:spTgt spid="13"/>
-                    </p:tgtEl>
-                  </p:cond>
-                </p:stCondLst>
-                <p:endSync evt="end" delay="0">
-                  <p:rtn val="all"/>
-                </p:endSync>
-                <p:childTnLst>
-                  <p:par>
-                    <p:cTn id="16" fill="hold">
-                      <p:stCondLst>
-                        <p:cond delay="0"/>
-                      </p:stCondLst>
-                      <p:childTnLst>
-                        <p:par>
-                          <p:cTn id="17" presetID="10" presetClass="entr" presetSubtype="0" fill="hold" grpId="0" nodeType="clickEffect">
-                            <p:stCondLst>
-                              <p:cond delay="0"/>
-                            </p:stCondLst>
-                            <p:childTnLst>
-                              <p:set>
-                                <p:cBhvr>
-                                  <p:cTn id="18" dur="1" fill="hold">
-                                    <p:stCondLst>
-                                      <p:cond delay="0"/>
-                                    </p:stCondLst>
-                                  </p:cTn>
-                                  <p:tgtEl>
-                                    <p:spTgt spid="17"/>
-                                  </p:tgtEl>
-                                  <p:attrNameLst>
-                                    <p:attrName>style.visibility</p:attrName>
-                                  </p:attrNameLst>
-                                </p:cBhvr>
-                                <p:to>
-                                  <p:strVal val="visible"/>
-                                </p:to>
-                              </p:set>
-                              <p:animEffect transition="in" filter="fade">
-                                <p:cBhvr>
-                                  <p:cTn id="19" dur="400"/>
-                                  <p:tgtEl>
-                                    <p:spTgt spid="17"/>
-                                  </p:tgtEl>
-                                </p:cBhvr>
-                              </p:animEffect>
-                            </p:childTnLst>
-                          </p:cTn>
-                        </p:par>
-                      </p:childTnLst>
-                    </p:cTn>
-                  </p:par>
-                </p:childTnLst>
-              </p:cTn>
-              <p:nextCondLst>
-                <p:cond evt="onClick" delay="0">
-                  <p:tgtEl>
-                    <p:spTgt spid="13"/>
-                  </p:tgtEl>
-                </p:cond>
-              </p:nextCondLst>
-            </p:seq>
-            <p:seq concurrent="1" nextAc="seek">
-              <p:cTn id="25" restart="whenNotActive" fill="hold" nodeType="interactiveSeq">
-                <p:stCondLst>
-                  <p:cond evt="onClick" delay="0">
-                    <p:tgtEl>
-                      <p:spTgt spid="18"/>
-                    </p:tgtEl>
-                  </p:cond>
-                </p:stCondLst>
-                <p:endSync evt="end" delay="0">
-                  <p:rtn val="all"/>
-                </p:endSync>
-                <p:childTnLst>
-                  <p:par>
-                    <p:cTn id="26" fill="hold">
-                      <p:stCondLst>
-                        <p:cond delay="0"/>
-                      </p:stCondLst>
-                      <p:childTnLst>
-                        <p:par>
-                          <p:cTn id="27" presetID="10" presetClass="entr" presetSubtype="0" fill="hold" grpId="0" nodeType="clickEffect">
-                            <p:stCondLst>
-                              <p:cond delay="0"/>
-                            </p:stCondLst>
-                            <p:childTnLst>
-                              <p:set>
-                                <p:cBhvr>
-                                  <p:cTn id="28" dur="1" fill="hold">
-                                    <p:stCondLst>
-                                      <p:cond delay="0"/>
-                                    </p:stCondLst>
-                                  </p:cTn>
-                                  <p:tgtEl>
-                                    <p:spTgt spid="22"/>
-                                  </p:tgtEl>
-                                  <p:attrNameLst>
-                                    <p:attrName>style.visibility</p:attrName>
-                                  </p:attrNameLst>
-                                </p:cBhvr>
-                                <p:to>
-                                  <p:strVal val="visible"/>
-                                </p:to>
-                              </p:set>
-                              <p:animEffect transition="in" filter="fade">
-                                <p:cBhvr>
-                                  <p:cTn id="29" dur="400"/>
-                                  <p:tgtEl>
-                                    <p:spTgt spid="22"/>
-                                  </p:tgtEl>
-                                </p:cBhvr>
-                              </p:animEffect>
-                            </p:childTnLst>
-                          </p:cTn>
-                        </p:par>
-                      </p:childTnLst>
-                    </p:cTn>
-                  </p:par>
-                </p:childTnLst>
-              </p:cTn>
-              <p:nextCondLst>
-                <p:cond evt="onClick" delay="0">
-                  <p:tgtEl>
-                    <p:spTgt spid="18"/>
-                  </p:tgtEl>
-                </p:cond>
-              </p:nextCondLst>
-            </p:seq>
-            <p:seq concurrent="1" nextAc="seek">
-              <p:cTn id="35" restart="whenNotActive" fill="hold" nodeType="interactiveSeq">
-                <p:stCondLst>
-                  <p:cond evt="onClick" delay="0">
-                    <p:tgtEl>
-                      <p:spTgt spid="23"/>
-                    </p:tgtEl>
-                  </p:cond>
-                </p:stCondLst>
-                <p:endSync evt="end" delay="0">
-                  <p:rtn val="all"/>
-                </p:endSync>
-                <p:childTnLst>
-                  <p:par>
-                    <p:cTn id="36" fill="hold">
-                      <p:stCondLst>
-                        <p:cond delay="0"/>
-                      </p:stCondLst>
-                      <p:childTnLst>
-                        <p:par>
-                          <p:cTn id="37" presetID="10" presetClass="entr" presetSubtype="0" fill="hold" grpId="0" nodeType="clickEffect">
-                            <p:stCondLst>
-                              <p:cond delay="0"/>
-                            </p:stCondLst>
-                            <p:childTnLst>
-                              <p:set>
-                                <p:cBhvr>
-                                  <p:cTn id="38" dur="1" fill="hold">
-                                    <p:stCondLst>
-                                      <p:cond delay="0"/>
-                                    </p:stCondLst>
-                                  </p:cTn>
-                                  <p:tgtEl>
-                                    <p:spTgt spid="27"/>
-                                  </p:tgtEl>
-                                  <p:attrNameLst>
-                                    <p:attrName>style.visibility</p:attrName>
-                                  </p:attrNameLst>
-                                </p:cBhvr>
-                                <p:to>
-                                  <p:strVal val="visible"/>
-                                </p:to>
-                              </p:set>
-                              <p:animEffect transition="in" filter="fade">
-                                <p:cBhvr>
-                                  <p:cTn id="39" dur="400"/>
-                                  <p:tgtEl>
-                                    <p:spTgt spid="27"/>
-                                  </p:tgtEl>
-                                </p:cBhvr>
-                              </p:animEffect>
-                            </p:childTnLst>
-                          </p:cTn>
-                        </p:par>
-                      </p:childTnLst>
-                    </p:cTn>
-                  </p:par>
-                </p:childTnLst>
-              </p:cTn>
-              <p:nextCondLst>
-                <p:cond evt="onClick" delay="0">
-                  <p:tgtEl>
-                    <p:spTgt spid="23"/>
-                  </p:tgtEl>
-                </p:cond>
-              </p:nextCondLst>
-            </p:seq>
-            <p:seq concurrent="1" nextAc="seek">
-              <p:cTn id="45" restart="whenNotActive" fill="hold" nodeType="interactiveSeq">
-                <p:stCondLst>
-                  <p:cond evt="onClick" delay="0">
-                    <p:tgtEl>
-                      <p:spTgt spid="28"/>
-                    </p:tgtEl>
-                  </p:cond>
-                </p:stCondLst>
-                <p:endSync evt="end" delay="0">
-                  <p:rtn val="all"/>
-                </p:endSync>
-                <p:childTnLst>
-                  <p:par>
-                    <p:cTn id="46" fill="hold">
-                      <p:stCondLst>
-                        <p:cond delay="0"/>
-                      </p:stCondLst>
-                      <p:childTnLst>
-                        <p:par>
-                          <p:cTn id="47" presetID="10" presetClass="entr" presetSubtype="0" fill="hold" grpId="0" nodeType="clickEffect">
-                            <p:stCondLst>
-                              <p:cond delay="0"/>
-                            </p:stCondLst>
-                            <p:childTnLst>
-                              <p:set>
-                                <p:cBhvr>
-                                  <p:cTn id="48" dur="1" fill="hold">
-                                    <p:stCondLst>
-                                      <p:cond delay="0"/>
-                                    </p:stCondLst>
-                                  </p:cTn>
-                                  <p:tgtEl>
-                                    <p:spTgt spid="32"/>
-                                  </p:tgtEl>
-                                  <p:attrNameLst>
-                                    <p:attrName>style.visibility</p:attrName>
-                                  </p:attrNameLst>
-                                </p:cBhvr>
-                                <p:to>
-                                  <p:strVal val="visible"/>
-                                </p:to>
-                              </p:set>
-                              <p:animEffect transition="in" filter="fade">
-                                <p:cBhvr>
-                                  <p:cTn id="49" dur="400"/>
-                                  <p:tgtEl>
-                                    <p:spTgt spid="32"/>
-                                  </p:tgtEl>
-                                </p:cBhvr>
-                              </p:animEffect>
-                            </p:childTnLst>
-                          </p:cTn>
-                        </p:par>
-                      </p:childTnLst>
-                    </p:cTn>
-                  </p:par>
-                </p:childTnLst>
-              </p:cTn>
-              <p:nextCondLst>
-                <p:cond evt="onClick" delay="0">
-                  <p:tgtEl>
-                    <p:spTgt spid="28"/>
-                  </p:tgtEl>
-                </p:cond>
-              </p:nextCondLst>
-            </p:seq>
-            <p:seq concurrent="1" nextAc="seek">
-              <p:cTn id="55" restart="whenNotActive" fill="hold" nodeType="interactiveSeq">
-                <p:stCondLst>
-                  <p:cond evt="onClick" delay="0">
-                    <p:tgtEl>
-                      <p:spTgt spid="33"/>
-                    </p:tgtEl>
-                  </p:cond>
-                </p:stCondLst>
-                <p:endSync evt="end" delay="0">
-                  <p:rtn val="all"/>
-                </p:endSync>
-                <p:childTnLst>
-                  <p:par>
-                    <p:cTn id="56" fill="hold">
-                      <p:stCondLst>
-                        <p:cond delay="0"/>
-                      </p:stCondLst>
-                      <p:childTnLst>
-                        <p:par>
-                          <p:cTn id="57" presetID="10" presetClass="entr" presetSubtype="0" fill="hold" grpId="0" nodeType="clickEffect">
-                            <p:stCondLst>
-                              <p:cond delay="0"/>
-                            </p:stCondLst>
-                            <p:childTnLst>
-                              <p:set>
-                                <p:cBhvr>
-                                  <p:cTn id="58" dur="1" fill="hold">
-                                    <p:stCondLst>
-                                      <p:cond delay="0"/>
-                                    </p:stCondLst>
-                                  </p:cTn>
-                                  <p:tgtEl>
-                                    <p:spTgt spid="37"/>
-                                  </p:tgtEl>
-                                  <p:attrNameLst>
-                                    <p:attrName>style.visibility</p:attrName>
-                                  </p:attrNameLst>
-                                </p:cBhvr>
-                                <p:to>
-                                  <p:strVal val="visible"/>
-                                </p:to>
-                              </p:set>
-                              <p:animEffect transition="in" filter="fade">
-                                <p:cBhvr>
-                                  <p:cTn id="59" dur="400"/>
-                                  <p:tgtEl>
-                                    <p:spTgt spid="37"/>
-                                  </p:tgtEl>
-                                </p:cBhvr>
-                              </p:animEffect>
-                            </p:childTnLst>
-                          </p:cTn>
-                        </p:par>
-                      </p:childTnLst>
-                    </p:cTn>
-                  </p:par>
-                </p:childTnLst>
-              </p:cTn>
-              <p:nextCondLst>
-                <p:cond evt="onClick" delay="0">
-                  <p:tgtEl>
-                    <p:spTgt spid="33"/>
-                  </p:tgtEl>
-                </p:cond>
-              </p:nextCondLst>
-            </p:seq>
-            <p:seq concurrent="1" nextAc="seek">
-              <p:cTn id="65" restart="whenNotActive" fill="hold" nodeType="interactiveSeq">
-                <p:stCondLst>
-                  <p:cond evt="onClick" delay="0">
-                    <p:tgtEl>
-                      <p:spTgt spid="38"/>
-                    </p:tgtEl>
-                  </p:cond>
-                </p:stCondLst>
-                <p:endSync evt="end" delay="0">
-                  <p:rtn val="all"/>
-                </p:endSync>
-                <p:childTnLst>
-                  <p:par>
-                    <p:cTn id="66" fill="hold">
-                      <p:stCondLst>
-                        <p:cond delay="0"/>
-                      </p:stCondLst>
-                      <p:childTnLst>
-                        <p:par>
-                          <p:cTn id="67" presetID="10" presetClass="entr" presetSubtype="0" fill="hold" grpId="0" nodeType="clickEffect">
-                            <p:stCondLst>
-                              <p:cond delay="0"/>
-                            </p:stCondLst>
-                            <p:childTnLst>
-                              <p:set>
-                                <p:cBhvr>
-                                  <p:cTn id="68" dur="1" fill="hold">
-                                    <p:stCondLst>
-                                      <p:cond delay="0"/>
-                                    </p:stCondLst>
-                                  </p:cTn>
-                                  <p:tgtEl>
-                                    <p:spTgt spid="42"/>
-                                  </p:tgtEl>
-                                  <p:attrNameLst>
-                                    <p:attrName>style.visibility</p:attrName>
-                                  </p:attrNameLst>
-                                </p:cBhvr>
-                                <p:to>
-                                  <p:strVal val="visible"/>
-                                </p:to>
-                              </p:set>
-                              <p:animEffect transition="in" filter="fade">
-                                <p:cBhvr>
-                                  <p:cTn id="69" dur="400"/>
-                                  <p:tgtEl>
-                                    <p:spTgt spid="42"/>
-                                  </p:tgtEl>
-                                </p:cBhvr>
-                              </p:animEffect>
-                            </p:childTnLst>
-                          </p:cTn>
-                        </p:par>
-                      </p:childTnLst>
-                    </p:cTn>
-                  </p:par>
-                </p:childTnLst>
-              </p:cTn>
-              <p:nextCondLst>
-                <p:cond evt="onClick" delay="0">
-                  <p:tgtEl>
-                    <p:spTgt spid="38"/>
-                  </p:tgtEl>
-                </p:cond>
-              </p:nextCondLst>
-            </p:seq>
-            <p:seq concurrent="1" nextAc="seek">
-              <p:cTn id="75" restart="whenNotActive" fill="hold" nodeType="interactiveSeq">
-                <p:stCondLst>
-                  <p:cond evt="onClick" delay="0">
-                    <p:tgtEl>
-                      <p:spTgt spid="38"/>
-                    </p:tgtEl>
-                  </p:cond>
-                </p:stCondLst>
-                <p:endSync evt="end" delay="0">
-                  <p:rtn val="all"/>
-                </p:endSync>
-                <p:childTnLst>
-                  <p:par>
-                    <p:cTn id="76" fill="hold">
-                      <p:stCondLst>
-                        <p:cond delay="0"/>
-                      </p:stCondLst>
-                      <p:childTnLst>
-                        <p:par>
-                          <p:cTn id="77" presetID="10" presetClass="entr" presetSubtype="0" fill="hold" grpId="0" nodeType="clickEffect">
-                            <p:stCondLst>
-                              <p:cond delay="0"/>
-                            </p:stCondLst>
-                            <p:childTnLst>
-                              <p:set>
-                                <p:cBhvr>
-                                  <p:cTn id="78" dur="1" fill="hold">
-                                    <p:stCondLst>
-                                      <p:cond delay="0"/>
-                                    </p:stCondLst>
-                                  </p:cTn>
-                                  <p:tgtEl>
-                                    <p:spTgt spid="43"/>
-                                  </p:tgtEl>
-                                  <p:attrNameLst>
-                                    <p:attrName>style.visibility</p:attrName>
-                                  </p:attrNameLst>
-                                </p:cBhvr>
-                                <p:to>
-                                  <p:strVal val="visible"/>
-                                </p:to>
-                              </p:set>
-                              <p:animEffect transition="in" filter="fade">
-                                <p:cBhvr>
-                                  <p:cTn id="79" dur="400"/>
-                                  <p:tgtEl>
-                                    <p:spTgt spid="43"/>
-                                  </p:tgtEl>
-                                </p:cBhvr>
-                              </p:animEffect>
-                            </p:childTnLst>
-                          </p:cTn>
-                        </p:par>
-                      </p:childTnLst>
-                    </p:cTn>
-                  </p:par>
-                </p:childTnLst>
-              </p:cTn>
-              <p:nextCondLst>
-                <p:cond evt="onClick" delay="0">
-                  <p:tgtEl>
-                    <p:spTgt spid="38"/>
                   </p:tgtEl>
                 </p:cond>
               </p:nextCondLst>
@@ -13848,7 +13733,7 @@
                 </a:solidFill>
                 <a:latin typeface="Inter"/>
               </a:rPr>
-              <a:t>Leerlingenversie — kioskmodus</a:t>
+              <a:t>Leerlingenversie — klik onthult</a:t>
             </a:r>
           </a:p>
         </p:txBody>
@@ -15038,7 +14923,7 @@
                 </a:solidFill>
                 <a:latin typeface="Inter"/>
               </a:rPr>
-              <a:t>Leerlingenversie — kioskmodus</a:t>
+              <a:t>Leerlingenversie — klik onthult</a:t>
             </a:r>
           </a:p>
         </p:txBody>
@@ -17045,7 +16930,7 @@
                 </a:solidFill>
                 <a:latin typeface="Inter"/>
               </a:rPr>
-              <a:t>Leerlingenversie — kioskmodus</a:t>
+              <a:t>Leerlingenversie — klik onthult</a:t>
             </a:r>
           </a:p>
         </p:txBody>
@@ -17107,7 +16992,326 @@
           <p:childTnLst>
             <p:seq concurrent="1" nextAc="seek">
               <p:cTn id="2" dur="indefinite" nodeType="mainSeq">
-                <p:childTnLst/>
+                <p:childTnLst>
+                  <p:par>
+                    <p:cTn id="3" fill="hold">
+                      <p:stCondLst>
+                        <p:cond delay="indefinite"/>
+                      </p:stCondLst>
+                      <p:childTnLst>
+                        <p:par>
+                          <p:cTn id="4" fill="hold">
+                            <p:stCondLst>
+                              <p:cond delay="0"/>
+                            </p:stCondLst>
+                            <p:childTnLst>
+                              <p:par>
+                                <p:cTn id="5" presetID="10" presetClass="entr" presetSubtype="0" fill="hold" grpId="0" nodeType="clickEffect">
+                                  <p:stCondLst>
+                                    <p:cond delay="0"/>
+                                  </p:stCondLst>
+                                  <p:childTnLst>
+                                    <p:set>
+                                      <p:cBhvr>
+                                        <p:cTn id="6" dur="1" fill="hold">
+                                          <p:stCondLst>
+                                            <p:cond delay="0"/>
+                                          </p:stCondLst>
+                                        </p:cTn>
+                                        <p:tgtEl>
+                                          <p:spTgt spid="14"/>
+                                        </p:tgtEl>
+                                        <p:attrNameLst>
+                                          <p:attrName>style.visibility</p:attrName>
+                                        </p:attrNameLst>
+                                      </p:cBhvr>
+                                      <p:to>
+                                        <p:strVal val="visible"/>
+                                      </p:to>
+                                    </p:set>
+                                    <p:animEffect transition="in" filter="fade">
+                                      <p:cBhvr>
+                                        <p:cTn id="7" dur="500"/>
+                                        <p:tgtEl>
+                                          <p:spTgt spid="14"/>
+                                        </p:tgtEl>
+                                      </p:cBhvr>
+                                    </p:animEffect>
+                                  </p:childTnLst>
+                                </p:cTn>
+                              </p:par>
+                            </p:childTnLst>
+                          </p:cTn>
+                        </p:par>
+                      </p:childTnLst>
+                    </p:cTn>
+                  </p:par>
+                  <p:par>
+                    <p:cTn id="8" fill="hold">
+                      <p:stCondLst>
+                        <p:cond delay="indefinite"/>
+                      </p:stCondLst>
+                      <p:childTnLst>
+                        <p:par>
+                          <p:cTn id="9" fill="hold">
+                            <p:stCondLst>
+                              <p:cond delay="0"/>
+                            </p:stCondLst>
+                            <p:childTnLst>
+                              <p:par>
+                                <p:cTn id="10" presetID="10" presetClass="entr" presetSubtype="0" fill="hold" grpId="0" nodeType="clickEffect">
+                                  <p:stCondLst>
+                                    <p:cond delay="0"/>
+                                  </p:stCondLst>
+                                  <p:childTnLst>
+                                    <p:set>
+                                      <p:cBhvr>
+                                        <p:cTn id="11" dur="1" fill="hold">
+                                          <p:stCondLst>
+                                            <p:cond delay="0"/>
+                                          </p:stCondLst>
+                                        </p:cTn>
+                                        <p:tgtEl>
+                                          <p:spTgt spid="20"/>
+                                        </p:tgtEl>
+                                        <p:attrNameLst>
+                                          <p:attrName>style.visibility</p:attrName>
+                                        </p:attrNameLst>
+                                      </p:cBhvr>
+                                      <p:to>
+                                        <p:strVal val="visible"/>
+                                      </p:to>
+                                    </p:set>
+                                    <p:animEffect transition="in" filter="fade">
+                                      <p:cBhvr>
+                                        <p:cTn id="12" dur="500"/>
+                                        <p:tgtEl>
+                                          <p:spTgt spid="20"/>
+                                        </p:tgtEl>
+                                      </p:cBhvr>
+                                    </p:animEffect>
+                                  </p:childTnLst>
+                                </p:cTn>
+                              </p:par>
+                            </p:childTnLst>
+                          </p:cTn>
+                        </p:par>
+                      </p:childTnLst>
+                    </p:cTn>
+                  </p:par>
+                  <p:par>
+                    <p:cTn id="13" fill="hold">
+                      <p:stCondLst>
+                        <p:cond delay="indefinite"/>
+                      </p:stCondLst>
+                      <p:childTnLst>
+                        <p:par>
+                          <p:cTn id="14" fill="hold">
+                            <p:stCondLst>
+                              <p:cond delay="0"/>
+                            </p:stCondLst>
+                            <p:childTnLst>
+                              <p:par>
+                                <p:cTn id="15" presetID="10" presetClass="entr" presetSubtype="0" fill="hold" grpId="0" nodeType="clickEffect">
+                                  <p:stCondLst>
+                                    <p:cond delay="0"/>
+                                  </p:stCondLst>
+                                  <p:childTnLst>
+                                    <p:set>
+                                      <p:cBhvr>
+                                        <p:cTn id="16" dur="1" fill="hold">
+                                          <p:stCondLst>
+                                            <p:cond delay="0"/>
+                                          </p:stCondLst>
+                                        </p:cTn>
+                                        <p:tgtEl>
+                                          <p:spTgt spid="26"/>
+                                        </p:tgtEl>
+                                        <p:attrNameLst>
+                                          <p:attrName>style.visibility</p:attrName>
+                                        </p:attrNameLst>
+                                      </p:cBhvr>
+                                      <p:to>
+                                        <p:strVal val="visible"/>
+                                      </p:to>
+                                    </p:set>
+                                    <p:animEffect transition="in" filter="fade">
+                                      <p:cBhvr>
+                                        <p:cTn id="17" dur="500"/>
+                                        <p:tgtEl>
+                                          <p:spTgt spid="26"/>
+                                        </p:tgtEl>
+                                      </p:cBhvr>
+                                    </p:animEffect>
+                                  </p:childTnLst>
+                                </p:cTn>
+                              </p:par>
+                            </p:childTnLst>
+                          </p:cTn>
+                        </p:par>
+                      </p:childTnLst>
+                    </p:cTn>
+                  </p:par>
+                  <p:par>
+                    <p:cTn id="18" fill="hold">
+                      <p:stCondLst>
+                        <p:cond delay="indefinite"/>
+                      </p:stCondLst>
+                      <p:childTnLst>
+                        <p:par>
+                          <p:cTn id="19" fill="hold">
+                            <p:stCondLst>
+                              <p:cond delay="0"/>
+                            </p:stCondLst>
+                            <p:childTnLst>
+                              <p:par>
+                                <p:cTn id="20" presetID="10" presetClass="entr" presetSubtype="0" fill="hold" grpId="0" nodeType="clickEffect">
+                                  <p:stCondLst>
+                                    <p:cond delay="0"/>
+                                  </p:stCondLst>
+                                  <p:childTnLst>
+                                    <p:set>
+                                      <p:cBhvr>
+                                        <p:cTn id="21" dur="1" fill="hold">
+                                          <p:stCondLst>
+                                            <p:cond delay="0"/>
+                                          </p:stCondLst>
+                                        </p:cTn>
+                                        <p:tgtEl>
+                                          <p:spTgt spid="32"/>
+                                        </p:tgtEl>
+                                        <p:attrNameLst>
+                                          <p:attrName>style.visibility</p:attrName>
+                                        </p:attrNameLst>
+                                      </p:cBhvr>
+                                      <p:to>
+                                        <p:strVal val="visible"/>
+                                      </p:to>
+                                    </p:set>
+                                    <p:animEffect transition="in" filter="fade">
+                                      <p:cBhvr>
+                                        <p:cTn id="22" dur="500"/>
+                                        <p:tgtEl>
+                                          <p:spTgt spid="32"/>
+                                        </p:tgtEl>
+                                      </p:cBhvr>
+                                    </p:animEffect>
+                                  </p:childTnLst>
+                                </p:cTn>
+                              </p:par>
+                            </p:childTnLst>
+                          </p:cTn>
+                        </p:par>
+                      </p:childTnLst>
+                    </p:cTn>
+                  </p:par>
+                  <p:par>
+                    <p:cTn id="23" fill="hold">
+                      <p:stCondLst>
+                        <p:cond delay="indefinite"/>
+                      </p:stCondLst>
+                      <p:childTnLst>
+                        <p:par>
+                          <p:cTn id="24" fill="hold">
+                            <p:stCondLst>
+                              <p:cond delay="0"/>
+                            </p:stCondLst>
+                            <p:childTnLst>
+                              <p:par>
+                                <p:cTn id="25" presetID="10" presetClass="entr" presetSubtype="0" fill="hold" grpId="0" nodeType="clickEffect">
+                                  <p:stCondLst>
+                                    <p:cond delay="0"/>
+                                  </p:stCondLst>
+                                  <p:childTnLst>
+                                    <p:set>
+                                      <p:cBhvr>
+                                        <p:cTn id="26" dur="1" fill="hold">
+                                          <p:stCondLst>
+                                            <p:cond delay="0"/>
+                                          </p:stCondLst>
+                                        </p:cTn>
+                                        <p:tgtEl>
+                                          <p:spTgt spid="37"/>
+                                        </p:tgtEl>
+                                        <p:attrNameLst>
+                                          <p:attrName>style.visibility</p:attrName>
+                                        </p:attrNameLst>
+                                      </p:cBhvr>
+                                      <p:to>
+                                        <p:strVal val="visible"/>
+                                      </p:to>
+                                    </p:set>
+                                    <p:animEffect transition="in" filter="fade">
+                                      <p:cBhvr>
+                                        <p:cTn id="27" dur="500"/>
+                                        <p:tgtEl>
+                                          <p:spTgt spid="37"/>
+                                        </p:tgtEl>
+                                      </p:cBhvr>
+                                    </p:animEffect>
+                                  </p:childTnLst>
+                                </p:cTn>
+                              </p:par>
+                            </p:childTnLst>
+                          </p:cTn>
+                        </p:par>
+                      </p:childTnLst>
+                    </p:cTn>
+                  </p:par>
+                  <p:par>
+                    <p:cTn id="28" fill="hold">
+                      <p:stCondLst>
+                        <p:cond delay="indefinite"/>
+                      </p:stCondLst>
+                      <p:childTnLst>
+                        <p:par>
+                          <p:cTn id="29" fill="hold">
+                            <p:stCondLst>
+                              <p:cond delay="0"/>
+                            </p:stCondLst>
+                            <p:childTnLst>
+                              <p:par>
+                                <p:cTn id="30" presetID="10" presetClass="entr" presetSubtype="0" fill="hold" grpId="0" nodeType="clickEffect">
+                                  <p:stCondLst>
+                                    <p:cond delay="0"/>
+                                  </p:stCondLst>
+                                  <p:childTnLst>
+                                    <p:set>
+                                      <p:cBhvr>
+                                        <p:cTn id="31" dur="1" fill="hold">
+                                          <p:stCondLst>
+                                            <p:cond delay="0"/>
+                                          </p:stCondLst>
+                                        </p:cTn>
+                                        <p:tgtEl>
+                                          <p:spTgt spid="38"/>
+                                        </p:tgtEl>
+                                        <p:attrNameLst>
+                                          <p:attrName>style.visibility</p:attrName>
+                                        </p:attrNameLst>
+                                      </p:cBhvr>
+                                      <p:to>
+                                        <p:strVal val="visible"/>
+                                      </p:to>
+                                    </p:set>
+                                    <p:animEffect transition="in" filter="fade">
+                                      <p:cBhvr>
+                                        <p:cTn id="32" dur="500"/>
+                                        <p:tgtEl>
+                                          <p:spTgt spid="38"/>
+                                        </p:tgtEl>
+                                      </p:cBhvr>
+                                    </p:animEffect>
+                                  </p:childTnLst>
+                                </p:cTn>
+                              </p:par>
+                            </p:childTnLst>
+                          </p:cTn>
+                        </p:par>
+                      </p:childTnLst>
+                    </p:cTn>
+                  </p:par>
+                </p:childTnLst>
               </p:cTn>
               <p:prevCondLst>
                 <p:cond evt="onPrev" delay="0">
@@ -17120,408 +17324,6 @@
                 <p:cond evt="onNext" delay="0">
                   <p:tgtEl>
                     <p:sldTgt/>
-                  </p:tgtEl>
-                </p:cond>
-              </p:nextCondLst>
-            </p:seq>
-            <p:seq concurrent="1" nextAc="seek">
-              <p:cTn id="5" restart="whenNotActive" fill="hold" nodeType="interactiveSeq">
-                <p:stCondLst>
-                  <p:cond evt="onClick" delay="0">
-                    <p:tgtEl>
-                      <p:spTgt spid="9"/>
-                    </p:tgtEl>
-                  </p:cond>
-                </p:stCondLst>
-                <p:endSync evt="end" delay="0">
-                  <p:rtn val="all"/>
-                </p:endSync>
-                <p:childTnLst>
-                  <p:par>
-                    <p:cTn id="6" fill="hold">
-                      <p:stCondLst>
-                        <p:cond delay="0"/>
-                      </p:stCondLst>
-                      <p:childTnLst>
-                        <p:par>
-                          <p:cTn id="7" presetID="10" presetClass="entr" presetSubtype="0" fill="hold" grpId="0" nodeType="clickEffect">
-                            <p:stCondLst>
-                              <p:cond delay="0"/>
-                            </p:stCondLst>
-                            <p:childTnLst>
-                              <p:set>
-                                <p:cBhvr>
-                                  <p:cTn id="8" dur="1" fill="hold">
-                                    <p:stCondLst>
-                                      <p:cond delay="0"/>
-                                    </p:stCondLst>
-                                  </p:cTn>
-                                  <p:tgtEl>
-                                    <p:spTgt spid="14"/>
-                                  </p:tgtEl>
-                                  <p:attrNameLst>
-                                    <p:attrName>style.visibility</p:attrName>
-                                  </p:attrNameLst>
-                                </p:cBhvr>
-                                <p:to>
-                                  <p:strVal val="visible"/>
-                                </p:to>
-                              </p:set>
-                              <p:animEffect transition="in" filter="fade">
-                                <p:cBhvr>
-                                  <p:cTn id="9" dur="400"/>
-                                  <p:tgtEl>
-                                    <p:spTgt spid="14"/>
-                                  </p:tgtEl>
-                                </p:cBhvr>
-                              </p:animEffect>
-                            </p:childTnLst>
-                          </p:cTn>
-                        </p:par>
-                      </p:childTnLst>
-                    </p:cTn>
-                  </p:par>
-                </p:childTnLst>
-              </p:cTn>
-              <p:nextCondLst>
-                <p:cond evt="onClick" delay="0">
-                  <p:tgtEl>
-                    <p:spTgt spid="9"/>
-                  </p:tgtEl>
-                </p:cond>
-              </p:nextCondLst>
-            </p:seq>
-            <p:seq concurrent="1" nextAc="seek">
-              <p:cTn id="15" restart="whenNotActive" fill="hold" nodeType="interactiveSeq">
-                <p:stCondLst>
-                  <p:cond evt="onClick" delay="0">
-                    <p:tgtEl>
-                      <p:spTgt spid="15"/>
-                    </p:tgtEl>
-                  </p:cond>
-                </p:stCondLst>
-                <p:endSync evt="end" delay="0">
-                  <p:rtn val="all"/>
-                </p:endSync>
-                <p:childTnLst>
-                  <p:par>
-                    <p:cTn id="16" fill="hold">
-                      <p:stCondLst>
-                        <p:cond delay="0"/>
-                      </p:stCondLst>
-                      <p:childTnLst>
-                        <p:par>
-                          <p:cTn id="17" presetID="10" presetClass="entr" presetSubtype="0" fill="hold" grpId="0" nodeType="clickEffect">
-                            <p:stCondLst>
-                              <p:cond delay="0"/>
-                            </p:stCondLst>
-                            <p:childTnLst>
-                              <p:set>
-                                <p:cBhvr>
-                                  <p:cTn id="18" dur="1" fill="hold">
-                                    <p:stCondLst>
-                                      <p:cond delay="0"/>
-                                    </p:stCondLst>
-                                  </p:cTn>
-                                  <p:tgtEl>
-                                    <p:spTgt spid="20"/>
-                                  </p:tgtEl>
-                                  <p:attrNameLst>
-                                    <p:attrName>style.visibility</p:attrName>
-                                  </p:attrNameLst>
-                                </p:cBhvr>
-                                <p:to>
-                                  <p:strVal val="visible"/>
-                                </p:to>
-                              </p:set>
-                              <p:animEffect transition="in" filter="fade">
-                                <p:cBhvr>
-                                  <p:cTn id="19" dur="400"/>
-                                  <p:tgtEl>
-                                    <p:spTgt spid="20"/>
-                                  </p:tgtEl>
-                                </p:cBhvr>
-                              </p:animEffect>
-                            </p:childTnLst>
-                          </p:cTn>
-                        </p:par>
-                      </p:childTnLst>
-                    </p:cTn>
-                  </p:par>
-                </p:childTnLst>
-              </p:cTn>
-              <p:nextCondLst>
-                <p:cond evt="onClick" delay="0">
-                  <p:tgtEl>
-                    <p:spTgt spid="15"/>
-                  </p:tgtEl>
-                </p:cond>
-              </p:nextCondLst>
-            </p:seq>
-            <p:seq concurrent="1" nextAc="seek">
-              <p:cTn id="25" restart="whenNotActive" fill="hold" nodeType="interactiveSeq">
-                <p:stCondLst>
-                  <p:cond evt="onClick" delay="0">
-                    <p:tgtEl>
-                      <p:spTgt spid="21"/>
-                    </p:tgtEl>
-                  </p:cond>
-                </p:stCondLst>
-                <p:endSync evt="end" delay="0">
-                  <p:rtn val="all"/>
-                </p:endSync>
-                <p:childTnLst>
-                  <p:par>
-                    <p:cTn id="26" fill="hold">
-                      <p:stCondLst>
-                        <p:cond delay="0"/>
-                      </p:stCondLst>
-                      <p:childTnLst>
-                        <p:par>
-                          <p:cTn id="27" presetID="10" presetClass="entr" presetSubtype="0" fill="hold" grpId="0" nodeType="clickEffect">
-                            <p:stCondLst>
-                              <p:cond delay="0"/>
-                            </p:stCondLst>
-                            <p:childTnLst>
-                              <p:set>
-                                <p:cBhvr>
-                                  <p:cTn id="28" dur="1" fill="hold">
-                                    <p:stCondLst>
-                                      <p:cond delay="0"/>
-                                    </p:stCondLst>
-                                  </p:cTn>
-                                  <p:tgtEl>
-                                    <p:spTgt spid="26"/>
-                                  </p:tgtEl>
-                                  <p:attrNameLst>
-                                    <p:attrName>style.visibility</p:attrName>
-                                  </p:attrNameLst>
-                                </p:cBhvr>
-                                <p:to>
-                                  <p:strVal val="visible"/>
-                                </p:to>
-                              </p:set>
-                              <p:animEffect transition="in" filter="fade">
-                                <p:cBhvr>
-                                  <p:cTn id="29" dur="400"/>
-                                  <p:tgtEl>
-                                    <p:spTgt spid="26"/>
-                                  </p:tgtEl>
-                                </p:cBhvr>
-                              </p:animEffect>
-                            </p:childTnLst>
-                          </p:cTn>
-                        </p:par>
-                      </p:childTnLst>
-                    </p:cTn>
-                  </p:par>
-                </p:childTnLst>
-              </p:cTn>
-              <p:nextCondLst>
-                <p:cond evt="onClick" delay="0">
-                  <p:tgtEl>
-                    <p:spTgt spid="21"/>
-                  </p:tgtEl>
-                </p:cond>
-              </p:nextCondLst>
-            </p:seq>
-            <p:seq concurrent="1" nextAc="seek">
-              <p:cTn id="35" restart="whenNotActive" fill="hold" nodeType="interactiveSeq">
-                <p:stCondLst>
-                  <p:cond evt="onClick" delay="0">
-                    <p:tgtEl>
-                      <p:spTgt spid="27"/>
-                    </p:tgtEl>
-                  </p:cond>
-                </p:stCondLst>
-                <p:endSync evt="end" delay="0">
-                  <p:rtn val="all"/>
-                </p:endSync>
-                <p:childTnLst>
-                  <p:par>
-                    <p:cTn id="36" fill="hold">
-                      <p:stCondLst>
-                        <p:cond delay="0"/>
-                      </p:stCondLst>
-                      <p:childTnLst>
-                        <p:par>
-                          <p:cTn id="37" presetID="10" presetClass="entr" presetSubtype="0" fill="hold" grpId="0" nodeType="clickEffect">
-                            <p:stCondLst>
-                              <p:cond delay="0"/>
-                            </p:stCondLst>
-                            <p:childTnLst>
-                              <p:set>
-                                <p:cBhvr>
-                                  <p:cTn id="38" dur="1" fill="hold">
-                                    <p:stCondLst>
-                                      <p:cond delay="0"/>
-                                    </p:stCondLst>
-                                  </p:cTn>
-                                  <p:tgtEl>
-                                    <p:spTgt spid="32"/>
-                                  </p:tgtEl>
-                                  <p:attrNameLst>
-                                    <p:attrName>style.visibility</p:attrName>
-                                  </p:attrNameLst>
-                                </p:cBhvr>
-                                <p:to>
-                                  <p:strVal val="visible"/>
-                                </p:to>
-                              </p:set>
-                              <p:animEffect transition="in" filter="fade">
-                                <p:cBhvr>
-                                  <p:cTn id="39" dur="400"/>
-                                  <p:tgtEl>
-                                    <p:spTgt spid="32"/>
-                                  </p:tgtEl>
-                                </p:cBhvr>
-                              </p:animEffect>
-                            </p:childTnLst>
-                          </p:cTn>
-                        </p:par>
-                      </p:childTnLst>
-                    </p:cTn>
-                  </p:par>
-                </p:childTnLst>
-              </p:cTn>
-              <p:nextCondLst>
-                <p:cond evt="onClick" delay="0">
-                  <p:tgtEl>
-                    <p:spTgt spid="27"/>
-                  </p:tgtEl>
-                </p:cond>
-              </p:nextCondLst>
-            </p:seq>
-            <p:seq concurrent="1" nextAc="seek">
-              <p:cTn id="45" restart="whenNotActive" fill="hold" nodeType="interactiveSeq">
-                <p:stCondLst>
-                  <p:cond evt="onClick" delay="0">
-                    <p:tgtEl>
-                      <p:spTgt spid="33"/>
-                    </p:tgtEl>
-                  </p:cond>
-                </p:stCondLst>
-                <p:endSync evt="end" delay="0">
-                  <p:rtn val="all"/>
-                </p:endSync>
-                <p:childTnLst>
-                  <p:par>
-                    <p:cTn id="46" fill="hold">
-                      <p:stCondLst>
-                        <p:cond delay="0"/>
-                      </p:stCondLst>
-                      <p:childTnLst>
-                        <p:par>
-                          <p:cTn id="47" presetID="10" presetClass="entr" presetSubtype="0" fill="hold" grpId="0" nodeType="clickEffect">
-                            <p:stCondLst>
-                              <p:cond delay="0"/>
-                            </p:stCondLst>
-                            <p:childTnLst>
-                              <p:set>
-                                <p:cBhvr>
-                                  <p:cTn id="48" dur="1" fill="hold">
-                                    <p:stCondLst>
-                                      <p:cond delay="0"/>
-                                    </p:stCondLst>
-                                  </p:cTn>
-                                  <p:tgtEl>
-                                    <p:spTgt spid="37"/>
-                                  </p:tgtEl>
-                                  <p:attrNameLst>
-                                    <p:attrName>style.visibility</p:attrName>
-                                  </p:attrNameLst>
-                                </p:cBhvr>
-                                <p:to>
-                                  <p:strVal val="visible"/>
-                                </p:to>
-                              </p:set>
-                              <p:animEffect transition="in" filter="fade">
-                                <p:cBhvr>
-                                  <p:cTn id="49" dur="400"/>
-                                  <p:tgtEl>
-                                    <p:spTgt spid="37"/>
-                                  </p:tgtEl>
-                                </p:cBhvr>
-                              </p:animEffect>
-                            </p:childTnLst>
-                          </p:cTn>
-                        </p:par>
-                      </p:childTnLst>
-                    </p:cTn>
-                  </p:par>
-                </p:childTnLst>
-              </p:cTn>
-              <p:nextCondLst>
-                <p:cond evt="onClick" delay="0">
-                  <p:tgtEl>
-                    <p:spTgt spid="33"/>
-                  </p:tgtEl>
-                </p:cond>
-              </p:nextCondLst>
-            </p:seq>
-            <p:seq concurrent="1" nextAc="seek">
-              <p:cTn id="55" restart="whenNotActive" fill="hold" nodeType="interactiveSeq">
-                <p:stCondLst>
-                  <p:cond evt="onClick" delay="0">
-                    <p:tgtEl>
-                      <p:spTgt spid="33"/>
-                    </p:tgtEl>
-                  </p:cond>
-                </p:stCondLst>
-                <p:endSync evt="end" delay="0">
-                  <p:rtn val="all"/>
-                </p:endSync>
-                <p:childTnLst>
-                  <p:par>
-                    <p:cTn id="56" fill="hold">
-                      <p:stCondLst>
-                        <p:cond delay="0"/>
-                      </p:stCondLst>
-                      <p:childTnLst>
-                        <p:par>
-                          <p:cTn id="57" presetID="10" presetClass="entr" presetSubtype="0" fill="hold" grpId="0" nodeType="clickEffect">
-                            <p:stCondLst>
-                              <p:cond delay="0"/>
-                            </p:stCondLst>
-                            <p:childTnLst>
-                              <p:set>
-                                <p:cBhvr>
-                                  <p:cTn id="58" dur="1" fill="hold">
-                                    <p:stCondLst>
-                                      <p:cond delay="0"/>
-                                    </p:stCondLst>
-                                  </p:cTn>
-                                  <p:tgtEl>
-                                    <p:spTgt spid="38"/>
-                                  </p:tgtEl>
-                                  <p:attrNameLst>
-                                    <p:attrName>style.visibility</p:attrName>
-                                  </p:attrNameLst>
-                                </p:cBhvr>
-                                <p:to>
-                                  <p:strVal val="visible"/>
-                                </p:to>
-                              </p:set>
-                              <p:animEffect transition="in" filter="fade">
-                                <p:cBhvr>
-                                  <p:cTn id="59" dur="400"/>
-                                  <p:tgtEl>
-                                    <p:spTgt spid="38"/>
-                                  </p:tgtEl>
-                                </p:cBhvr>
-                              </p:animEffect>
-                            </p:childTnLst>
-                          </p:cTn>
-                        </p:par>
-                      </p:childTnLst>
-                    </p:cTn>
-                  </p:par>
-                </p:childTnLst>
-              </p:cTn>
-              <p:nextCondLst>
-                <p:cond evt="onClick" delay="0">
-                  <p:tgtEl>
-                    <p:spTgt spid="33"/>
                   </p:tgtEl>
                 </p:cond>
               </p:nextCondLst>
@@ -20746,7 +20548,7 @@
                 </a:solidFill>
                 <a:latin typeface="Inter"/>
               </a:rPr>
-              <a:t>Leerlingenversie — kioskmodus</a:t>
+              <a:t>Leerlingenversie — klik onthult</a:t>
             </a:r>
           </a:p>
         </p:txBody>
@@ -23788,7 +23590,7 @@
                 </a:solidFill>
                 <a:latin typeface="Inter"/>
               </a:rPr>
-              <a:t>Leerlingenversie — kioskmodus</a:t>
+              <a:t>Leerlingenversie — klik onthult</a:t>
             </a:r>
           </a:p>
         </p:txBody>
@@ -25990,7 +25792,7 @@
                 </a:solidFill>
                 <a:latin typeface="Inter"/>
               </a:rPr>
-              <a:t>Leerlingenversie — kioskmodus</a:t>
+              <a:t>Leerlingenversie — klik onthult</a:t>
             </a:r>
           </a:p>
         </p:txBody>
@@ -28029,7 +27831,7 @@
                 </a:solidFill>
                 <a:latin typeface="Inter"/>
               </a:rPr>
-              <a:t>Leerlingenversie — kioskmodus</a:t>
+              <a:t>Leerlingenversie — klik onthult</a:t>
             </a:r>
           </a:p>
         </p:txBody>
@@ -28091,7 +27893,379 @@
           <p:childTnLst>
             <p:seq concurrent="1" nextAc="seek">
               <p:cTn id="2" dur="indefinite" nodeType="mainSeq">
-                <p:childTnLst/>
+                <p:childTnLst>
+                  <p:par>
+                    <p:cTn id="3" fill="hold">
+                      <p:stCondLst>
+                        <p:cond delay="indefinite"/>
+                      </p:stCondLst>
+                      <p:childTnLst>
+                        <p:par>
+                          <p:cTn id="4" fill="hold">
+                            <p:stCondLst>
+                              <p:cond delay="0"/>
+                            </p:stCondLst>
+                            <p:childTnLst>
+                              <p:par>
+                                <p:cTn id="5" presetID="10" presetClass="entr" presetSubtype="0" fill="hold" grpId="0" nodeType="clickEffect">
+                                  <p:stCondLst>
+                                    <p:cond delay="0"/>
+                                  </p:stCondLst>
+                                  <p:childTnLst>
+                                    <p:set>
+                                      <p:cBhvr>
+                                        <p:cTn id="6" dur="1" fill="hold">
+                                          <p:stCondLst>
+                                            <p:cond delay="0"/>
+                                          </p:stCondLst>
+                                        </p:cTn>
+                                        <p:tgtEl>
+                                          <p:spTgt spid="11"/>
+                                        </p:tgtEl>
+                                        <p:attrNameLst>
+                                          <p:attrName>style.visibility</p:attrName>
+                                        </p:attrNameLst>
+                                      </p:cBhvr>
+                                      <p:to>
+                                        <p:strVal val="visible"/>
+                                      </p:to>
+                                    </p:set>
+                                    <p:animEffect transition="in" filter="fade">
+                                      <p:cBhvr>
+                                        <p:cTn id="7" dur="500"/>
+                                        <p:tgtEl>
+                                          <p:spTgt spid="11"/>
+                                        </p:tgtEl>
+                                      </p:cBhvr>
+                                    </p:animEffect>
+                                  </p:childTnLst>
+                                </p:cTn>
+                              </p:par>
+                            </p:childTnLst>
+                          </p:cTn>
+                        </p:par>
+                      </p:childTnLst>
+                    </p:cTn>
+                  </p:par>
+                  <p:par>
+                    <p:cTn id="8" fill="hold">
+                      <p:stCondLst>
+                        <p:cond delay="indefinite"/>
+                      </p:stCondLst>
+                      <p:childTnLst>
+                        <p:par>
+                          <p:cTn id="9" fill="hold">
+                            <p:stCondLst>
+                              <p:cond delay="0"/>
+                            </p:stCondLst>
+                            <p:childTnLst>
+                              <p:par>
+                                <p:cTn id="10" presetID="10" presetClass="entr" presetSubtype="0" fill="hold" grpId="0" nodeType="clickEffect">
+                                  <p:stCondLst>
+                                    <p:cond delay="0"/>
+                                  </p:stCondLst>
+                                  <p:childTnLst>
+                                    <p:set>
+                                      <p:cBhvr>
+                                        <p:cTn id="11" dur="1" fill="hold">
+                                          <p:stCondLst>
+                                            <p:cond delay="0"/>
+                                          </p:stCondLst>
+                                        </p:cTn>
+                                        <p:tgtEl>
+                                          <p:spTgt spid="15"/>
+                                        </p:tgtEl>
+                                        <p:attrNameLst>
+                                          <p:attrName>style.visibility</p:attrName>
+                                        </p:attrNameLst>
+                                      </p:cBhvr>
+                                      <p:to>
+                                        <p:strVal val="visible"/>
+                                      </p:to>
+                                    </p:set>
+                                    <p:animEffect transition="in" filter="fade">
+                                      <p:cBhvr>
+                                        <p:cTn id="12" dur="500"/>
+                                        <p:tgtEl>
+                                          <p:spTgt spid="15"/>
+                                        </p:tgtEl>
+                                      </p:cBhvr>
+                                    </p:animEffect>
+                                  </p:childTnLst>
+                                </p:cTn>
+                              </p:par>
+                            </p:childTnLst>
+                          </p:cTn>
+                        </p:par>
+                      </p:childTnLst>
+                    </p:cTn>
+                  </p:par>
+                  <p:par>
+                    <p:cTn id="13" fill="hold">
+                      <p:stCondLst>
+                        <p:cond delay="indefinite"/>
+                      </p:stCondLst>
+                      <p:childTnLst>
+                        <p:par>
+                          <p:cTn id="14" fill="hold">
+                            <p:stCondLst>
+                              <p:cond delay="0"/>
+                            </p:stCondLst>
+                            <p:childTnLst>
+                              <p:par>
+                                <p:cTn id="15" presetID="10" presetClass="entr" presetSubtype="0" fill="hold" grpId="0" nodeType="clickEffect">
+                                  <p:stCondLst>
+                                    <p:cond delay="0"/>
+                                  </p:stCondLst>
+                                  <p:childTnLst>
+                                    <p:set>
+                                      <p:cBhvr>
+                                        <p:cTn id="16" dur="1" fill="hold">
+                                          <p:stCondLst>
+                                            <p:cond delay="0"/>
+                                          </p:stCondLst>
+                                        </p:cTn>
+                                        <p:tgtEl>
+                                          <p:spTgt spid="19"/>
+                                        </p:tgtEl>
+                                        <p:attrNameLst>
+                                          <p:attrName>style.visibility</p:attrName>
+                                        </p:attrNameLst>
+                                      </p:cBhvr>
+                                      <p:to>
+                                        <p:strVal val="visible"/>
+                                      </p:to>
+                                    </p:set>
+                                    <p:animEffect transition="in" filter="fade">
+                                      <p:cBhvr>
+                                        <p:cTn id="17" dur="500"/>
+                                        <p:tgtEl>
+                                          <p:spTgt spid="19"/>
+                                        </p:tgtEl>
+                                      </p:cBhvr>
+                                    </p:animEffect>
+                                  </p:childTnLst>
+                                </p:cTn>
+                              </p:par>
+                            </p:childTnLst>
+                          </p:cTn>
+                        </p:par>
+                      </p:childTnLst>
+                    </p:cTn>
+                  </p:par>
+                  <p:par>
+                    <p:cTn id="18" fill="hold">
+                      <p:stCondLst>
+                        <p:cond delay="indefinite"/>
+                      </p:stCondLst>
+                      <p:childTnLst>
+                        <p:par>
+                          <p:cTn id="19" fill="hold">
+                            <p:stCondLst>
+                              <p:cond delay="0"/>
+                            </p:stCondLst>
+                            <p:childTnLst>
+                              <p:par>
+                                <p:cTn id="20" presetID="10" presetClass="entr" presetSubtype="0" fill="hold" grpId="0" nodeType="clickEffect">
+                                  <p:stCondLst>
+                                    <p:cond delay="0"/>
+                                  </p:stCondLst>
+                                  <p:childTnLst>
+                                    <p:set>
+                                      <p:cBhvr>
+                                        <p:cTn id="21" dur="1" fill="hold">
+                                          <p:stCondLst>
+                                            <p:cond delay="0"/>
+                                          </p:stCondLst>
+                                        </p:cTn>
+                                        <p:tgtEl>
+                                          <p:spTgt spid="23"/>
+                                        </p:tgtEl>
+                                        <p:attrNameLst>
+                                          <p:attrName>style.visibility</p:attrName>
+                                        </p:attrNameLst>
+                                      </p:cBhvr>
+                                      <p:to>
+                                        <p:strVal val="visible"/>
+                                      </p:to>
+                                    </p:set>
+                                    <p:animEffect transition="in" filter="fade">
+                                      <p:cBhvr>
+                                        <p:cTn id="22" dur="500"/>
+                                        <p:tgtEl>
+                                          <p:spTgt spid="23"/>
+                                        </p:tgtEl>
+                                      </p:cBhvr>
+                                    </p:animEffect>
+                                  </p:childTnLst>
+                                </p:cTn>
+                              </p:par>
+                            </p:childTnLst>
+                          </p:cTn>
+                        </p:par>
+                      </p:childTnLst>
+                    </p:cTn>
+                  </p:par>
+                  <p:par>
+                    <p:cTn id="23" fill="hold">
+                      <p:stCondLst>
+                        <p:cond delay="indefinite"/>
+                      </p:stCondLst>
+                      <p:childTnLst>
+                        <p:par>
+                          <p:cTn id="24" fill="hold">
+                            <p:stCondLst>
+                              <p:cond delay="0"/>
+                            </p:stCondLst>
+                            <p:childTnLst>
+                              <p:par>
+                                <p:cTn id="25" presetID="10" presetClass="entr" presetSubtype="0" fill="hold" grpId="0" nodeType="clickEffect">
+                                  <p:stCondLst>
+                                    <p:cond delay="0"/>
+                                  </p:stCondLst>
+                                  <p:childTnLst>
+                                    <p:set>
+                                      <p:cBhvr>
+                                        <p:cTn id="26" dur="1" fill="hold">
+                                          <p:stCondLst>
+                                            <p:cond delay="0"/>
+                                          </p:stCondLst>
+                                        </p:cTn>
+                                        <p:tgtEl>
+                                          <p:spTgt spid="27"/>
+                                        </p:tgtEl>
+                                        <p:attrNameLst>
+                                          <p:attrName>style.visibility</p:attrName>
+                                        </p:attrNameLst>
+                                      </p:cBhvr>
+                                      <p:to>
+                                        <p:strVal val="visible"/>
+                                      </p:to>
+                                    </p:set>
+                                    <p:animEffect transition="in" filter="fade">
+                                      <p:cBhvr>
+                                        <p:cTn id="27" dur="500"/>
+                                        <p:tgtEl>
+                                          <p:spTgt spid="27"/>
+                                        </p:tgtEl>
+                                      </p:cBhvr>
+                                    </p:animEffect>
+                                  </p:childTnLst>
+                                </p:cTn>
+                              </p:par>
+                            </p:childTnLst>
+                          </p:cTn>
+                        </p:par>
+                      </p:childTnLst>
+                    </p:cTn>
+                  </p:par>
+                  <p:par>
+                    <p:cTn id="28" fill="hold">
+                      <p:stCondLst>
+                        <p:cond delay="indefinite"/>
+                      </p:stCondLst>
+                      <p:childTnLst>
+                        <p:par>
+                          <p:cTn id="29" fill="hold">
+                            <p:stCondLst>
+                              <p:cond delay="0"/>
+                            </p:stCondLst>
+                            <p:childTnLst>
+                              <p:par>
+                                <p:cTn id="30" presetID="10" presetClass="entr" presetSubtype="0" fill="hold" grpId="0" nodeType="clickEffect">
+                                  <p:stCondLst>
+                                    <p:cond delay="0"/>
+                                  </p:stCondLst>
+                                  <p:childTnLst>
+                                    <p:set>
+                                      <p:cBhvr>
+                                        <p:cTn id="31" dur="1" fill="hold">
+                                          <p:stCondLst>
+                                            <p:cond delay="0"/>
+                                          </p:stCondLst>
+                                        </p:cTn>
+                                        <p:tgtEl>
+                                          <p:spTgt spid="32"/>
+                                        </p:tgtEl>
+                                        <p:attrNameLst>
+                                          <p:attrName>style.visibility</p:attrName>
+                                        </p:attrNameLst>
+                                      </p:cBhvr>
+                                      <p:to>
+                                        <p:strVal val="visible"/>
+                                      </p:to>
+                                    </p:set>
+                                    <p:animEffect transition="in" filter="fade">
+                                      <p:cBhvr>
+                                        <p:cTn id="32" dur="500"/>
+                                        <p:tgtEl>
+                                          <p:spTgt spid="32"/>
+                                        </p:tgtEl>
+                                      </p:cBhvr>
+                                    </p:animEffect>
+                                  </p:childTnLst>
+                                </p:cTn>
+                              </p:par>
+                            </p:childTnLst>
+                          </p:cTn>
+                        </p:par>
+                      </p:childTnLst>
+                    </p:cTn>
+                  </p:par>
+                  <p:par>
+                    <p:cTn id="33" fill="hold">
+                      <p:stCondLst>
+                        <p:cond delay="indefinite"/>
+                      </p:stCondLst>
+                      <p:childTnLst>
+                        <p:par>
+                          <p:cTn id="34" fill="hold">
+                            <p:stCondLst>
+                              <p:cond delay="0"/>
+                            </p:stCondLst>
+                            <p:childTnLst>
+                              <p:par>
+                                <p:cTn id="35" presetID="10" presetClass="entr" presetSubtype="0" fill="hold" grpId="0" nodeType="clickEffect">
+                                  <p:stCondLst>
+                                    <p:cond delay="0"/>
+                                  </p:stCondLst>
+                                  <p:childTnLst>
+                                    <p:set>
+                                      <p:cBhvr>
+                                        <p:cTn id="36" dur="1" fill="hold">
+                                          <p:stCondLst>
+                                            <p:cond delay="0"/>
+                                          </p:stCondLst>
+                                        </p:cTn>
+                                        <p:tgtEl>
+                                          <p:spTgt spid="33"/>
+                                        </p:tgtEl>
+                                        <p:attrNameLst>
+                                          <p:attrName>style.visibility</p:attrName>
+                                        </p:attrNameLst>
+                                      </p:cBhvr>
+                                      <p:to>
+                                        <p:strVal val="visible"/>
+                                      </p:to>
+                                    </p:set>
+                                    <p:animEffect transition="in" filter="fade">
+                                      <p:cBhvr>
+                                        <p:cTn id="37" dur="500"/>
+                                        <p:tgtEl>
+                                          <p:spTgt spid="33"/>
+                                        </p:tgtEl>
+                                      </p:cBhvr>
+                                    </p:animEffect>
+                                  </p:childTnLst>
+                                </p:cTn>
+                              </p:par>
+                            </p:childTnLst>
+                          </p:cTn>
+                        </p:par>
+                      </p:childTnLst>
+                    </p:cTn>
+                  </p:par>
+                </p:childTnLst>
               </p:cTn>
               <p:prevCondLst>
                 <p:cond evt="onPrev" delay="0">
@@ -28104,475 +28278,6 @@
                 <p:cond evt="onNext" delay="0">
                   <p:tgtEl>
                     <p:sldTgt/>
-                  </p:tgtEl>
-                </p:cond>
-              </p:nextCondLst>
-            </p:seq>
-            <p:seq concurrent="1" nextAc="seek">
-              <p:cTn id="5" restart="whenNotActive" fill="hold" nodeType="interactiveSeq">
-                <p:stCondLst>
-                  <p:cond evt="onClick" delay="0">
-                    <p:tgtEl>
-                      <p:spTgt spid="8"/>
-                    </p:tgtEl>
-                  </p:cond>
-                </p:stCondLst>
-                <p:endSync evt="end" delay="0">
-                  <p:rtn val="all"/>
-                </p:endSync>
-                <p:childTnLst>
-                  <p:par>
-                    <p:cTn id="6" fill="hold">
-                      <p:stCondLst>
-                        <p:cond delay="0"/>
-                      </p:stCondLst>
-                      <p:childTnLst>
-                        <p:par>
-                          <p:cTn id="7" presetID="10" presetClass="entr" presetSubtype="0" fill="hold" grpId="0" nodeType="clickEffect">
-                            <p:stCondLst>
-                              <p:cond delay="0"/>
-                            </p:stCondLst>
-                            <p:childTnLst>
-                              <p:set>
-                                <p:cBhvr>
-                                  <p:cTn id="8" dur="1" fill="hold">
-                                    <p:stCondLst>
-                                      <p:cond delay="0"/>
-                                    </p:stCondLst>
-                                  </p:cTn>
-                                  <p:tgtEl>
-                                    <p:spTgt spid="11"/>
-                                  </p:tgtEl>
-                                  <p:attrNameLst>
-                                    <p:attrName>style.visibility</p:attrName>
-                                  </p:attrNameLst>
-                                </p:cBhvr>
-                                <p:to>
-                                  <p:strVal val="visible"/>
-                                </p:to>
-                              </p:set>
-                              <p:animEffect transition="in" filter="fade">
-                                <p:cBhvr>
-                                  <p:cTn id="9" dur="400"/>
-                                  <p:tgtEl>
-                                    <p:spTgt spid="11"/>
-                                  </p:tgtEl>
-                                </p:cBhvr>
-                              </p:animEffect>
-                            </p:childTnLst>
-                          </p:cTn>
-                        </p:par>
-                      </p:childTnLst>
-                    </p:cTn>
-                  </p:par>
-                </p:childTnLst>
-              </p:cTn>
-              <p:nextCondLst>
-                <p:cond evt="onClick" delay="0">
-                  <p:tgtEl>
-                    <p:spTgt spid="8"/>
-                  </p:tgtEl>
-                </p:cond>
-              </p:nextCondLst>
-            </p:seq>
-            <p:seq concurrent="1" nextAc="seek">
-              <p:cTn id="15" restart="whenNotActive" fill="hold" nodeType="interactiveSeq">
-                <p:stCondLst>
-                  <p:cond evt="onClick" delay="0">
-                    <p:tgtEl>
-                      <p:spTgt spid="12"/>
-                    </p:tgtEl>
-                  </p:cond>
-                </p:stCondLst>
-                <p:endSync evt="end" delay="0">
-                  <p:rtn val="all"/>
-                </p:endSync>
-                <p:childTnLst>
-                  <p:par>
-                    <p:cTn id="16" fill="hold">
-                      <p:stCondLst>
-                        <p:cond delay="0"/>
-                      </p:stCondLst>
-                      <p:childTnLst>
-                        <p:par>
-                          <p:cTn id="17" presetID="10" presetClass="entr" presetSubtype="0" fill="hold" grpId="0" nodeType="clickEffect">
-                            <p:stCondLst>
-                              <p:cond delay="0"/>
-                            </p:stCondLst>
-                            <p:childTnLst>
-                              <p:set>
-                                <p:cBhvr>
-                                  <p:cTn id="18" dur="1" fill="hold">
-                                    <p:stCondLst>
-                                      <p:cond delay="0"/>
-                                    </p:stCondLst>
-                                  </p:cTn>
-                                  <p:tgtEl>
-                                    <p:spTgt spid="15"/>
-                                  </p:tgtEl>
-                                  <p:attrNameLst>
-                                    <p:attrName>style.visibility</p:attrName>
-                                  </p:attrNameLst>
-                                </p:cBhvr>
-                                <p:to>
-                                  <p:strVal val="visible"/>
-                                </p:to>
-                              </p:set>
-                              <p:animEffect transition="in" filter="fade">
-                                <p:cBhvr>
-                                  <p:cTn id="19" dur="400"/>
-                                  <p:tgtEl>
-                                    <p:spTgt spid="15"/>
-                                  </p:tgtEl>
-                                </p:cBhvr>
-                              </p:animEffect>
-                            </p:childTnLst>
-                          </p:cTn>
-                        </p:par>
-                      </p:childTnLst>
-                    </p:cTn>
-                  </p:par>
-                </p:childTnLst>
-              </p:cTn>
-              <p:nextCondLst>
-                <p:cond evt="onClick" delay="0">
-                  <p:tgtEl>
-                    <p:spTgt spid="12"/>
-                  </p:tgtEl>
-                </p:cond>
-              </p:nextCondLst>
-            </p:seq>
-            <p:seq concurrent="1" nextAc="seek">
-              <p:cTn id="25" restart="whenNotActive" fill="hold" nodeType="interactiveSeq">
-                <p:stCondLst>
-                  <p:cond evt="onClick" delay="0">
-                    <p:tgtEl>
-                      <p:spTgt spid="16"/>
-                    </p:tgtEl>
-                  </p:cond>
-                </p:stCondLst>
-                <p:endSync evt="end" delay="0">
-                  <p:rtn val="all"/>
-                </p:endSync>
-                <p:childTnLst>
-                  <p:par>
-                    <p:cTn id="26" fill="hold">
-                      <p:stCondLst>
-                        <p:cond delay="0"/>
-                      </p:stCondLst>
-                      <p:childTnLst>
-                        <p:par>
-                          <p:cTn id="27" presetID="10" presetClass="entr" presetSubtype="0" fill="hold" grpId="0" nodeType="clickEffect">
-                            <p:stCondLst>
-                              <p:cond delay="0"/>
-                            </p:stCondLst>
-                            <p:childTnLst>
-                              <p:set>
-                                <p:cBhvr>
-                                  <p:cTn id="28" dur="1" fill="hold">
-                                    <p:stCondLst>
-                                      <p:cond delay="0"/>
-                                    </p:stCondLst>
-                                  </p:cTn>
-                                  <p:tgtEl>
-                                    <p:spTgt spid="19"/>
-                                  </p:tgtEl>
-                                  <p:attrNameLst>
-                                    <p:attrName>style.visibility</p:attrName>
-                                  </p:attrNameLst>
-                                </p:cBhvr>
-                                <p:to>
-                                  <p:strVal val="visible"/>
-                                </p:to>
-                              </p:set>
-                              <p:animEffect transition="in" filter="fade">
-                                <p:cBhvr>
-                                  <p:cTn id="29" dur="400"/>
-                                  <p:tgtEl>
-                                    <p:spTgt spid="19"/>
-                                  </p:tgtEl>
-                                </p:cBhvr>
-                              </p:animEffect>
-                            </p:childTnLst>
-                          </p:cTn>
-                        </p:par>
-                      </p:childTnLst>
-                    </p:cTn>
-                  </p:par>
-                </p:childTnLst>
-              </p:cTn>
-              <p:nextCondLst>
-                <p:cond evt="onClick" delay="0">
-                  <p:tgtEl>
-                    <p:spTgt spid="16"/>
-                  </p:tgtEl>
-                </p:cond>
-              </p:nextCondLst>
-            </p:seq>
-            <p:seq concurrent="1" nextAc="seek">
-              <p:cTn id="35" restart="whenNotActive" fill="hold" nodeType="interactiveSeq">
-                <p:stCondLst>
-                  <p:cond evt="onClick" delay="0">
-                    <p:tgtEl>
-                      <p:spTgt spid="20"/>
-                    </p:tgtEl>
-                  </p:cond>
-                </p:stCondLst>
-                <p:endSync evt="end" delay="0">
-                  <p:rtn val="all"/>
-                </p:endSync>
-                <p:childTnLst>
-                  <p:par>
-                    <p:cTn id="36" fill="hold">
-                      <p:stCondLst>
-                        <p:cond delay="0"/>
-                      </p:stCondLst>
-                      <p:childTnLst>
-                        <p:par>
-                          <p:cTn id="37" presetID="10" presetClass="entr" presetSubtype="0" fill="hold" grpId="0" nodeType="clickEffect">
-                            <p:stCondLst>
-                              <p:cond delay="0"/>
-                            </p:stCondLst>
-                            <p:childTnLst>
-                              <p:set>
-                                <p:cBhvr>
-                                  <p:cTn id="38" dur="1" fill="hold">
-                                    <p:stCondLst>
-                                      <p:cond delay="0"/>
-                                    </p:stCondLst>
-                                  </p:cTn>
-                                  <p:tgtEl>
-                                    <p:spTgt spid="23"/>
-                                  </p:tgtEl>
-                                  <p:attrNameLst>
-                                    <p:attrName>style.visibility</p:attrName>
-                                  </p:attrNameLst>
-                                </p:cBhvr>
-                                <p:to>
-                                  <p:strVal val="visible"/>
-                                </p:to>
-                              </p:set>
-                              <p:animEffect transition="in" filter="fade">
-                                <p:cBhvr>
-                                  <p:cTn id="39" dur="400"/>
-                                  <p:tgtEl>
-                                    <p:spTgt spid="23"/>
-                                  </p:tgtEl>
-                                </p:cBhvr>
-                              </p:animEffect>
-                            </p:childTnLst>
-                          </p:cTn>
-                        </p:par>
-                      </p:childTnLst>
-                    </p:cTn>
-                  </p:par>
-                </p:childTnLst>
-              </p:cTn>
-              <p:nextCondLst>
-                <p:cond evt="onClick" delay="0">
-                  <p:tgtEl>
-                    <p:spTgt spid="20"/>
-                  </p:tgtEl>
-                </p:cond>
-              </p:nextCondLst>
-            </p:seq>
-            <p:seq concurrent="1" nextAc="seek">
-              <p:cTn id="45" restart="whenNotActive" fill="hold" nodeType="interactiveSeq">
-                <p:stCondLst>
-                  <p:cond evt="onClick" delay="0">
-                    <p:tgtEl>
-                      <p:spTgt spid="24"/>
-                    </p:tgtEl>
-                  </p:cond>
-                </p:stCondLst>
-                <p:endSync evt="end" delay="0">
-                  <p:rtn val="all"/>
-                </p:endSync>
-                <p:childTnLst>
-                  <p:par>
-                    <p:cTn id="46" fill="hold">
-                      <p:stCondLst>
-                        <p:cond delay="0"/>
-                      </p:stCondLst>
-                      <p:childTnLst>
-                        <p:par>
-                          <p:cTn id="47" presetID="10" presetClass="entr" presetSubtype="0" fill="hold" grpId="0" nodeType="clickEffect">
-                            <p:stCondLst>
-                              <p:cond delay="0"/>
-                            </p:stCondLst>
-                            <p:childTnLst>
-                              <p:set>
-                                <p:cBhvr>
-                                  <p:cTn id="48" dur="1" fill="hold">
-                                    <p:stCondLst>
-                                      <p:cond delay="0"/>
-                                    </p:stCondLst>
-                                  </p:cTn>
-                                  <p:tgtEl>
-                                    <p:spTgt spid="27"/>
-                                  </p:tgtEl>
-                                  <p:attrNameLst>
-                                    <p:attrName>style.visibility</p:attrName>
-                                  </p:attrNameLst>
-                                </p:cBhvr>
-                                <p:to>
-                                  <p:strVal val="visible"/>
-                                </p:to>
-                              </p:set>
-                              <p:animEffect transition="in" filter="fade">
-                                <p:cBhvr>
-                                  <p:cTn id="49" dur="400"/>
-                                  <p:tgtEl>
-                                    <p:spTgt spid="27"/>
-                                  </p:tgtEl>
-                                </p:cBhvr>
-                              </p:animEffect>
-                            </p:childTnLst>
-                          </p:cTn>
-                        </p:par>
-                      </p:childTnLst>
-                    </p:cTn>
-                  </p:par>
-                </p:childTnLst>
-              </p:cTn>
-              <p:nextCondLst>
-                <p:cond evt="onClick" delay="0">
-                  <p:tgtEl>
-                    <p:spTgt spid="24"/>
-                  </p:tgtEl>
-                </p:cond>
-              </p:nextCondLst>
-            </p:seq>
-            <p:seq concurrent="1" nextAc="seek">
-              <p:cTn id="55" restart="whenNotActive" fill="hold" nodeType="interactiveSeq">
-                <p:stCondLst>
-                  <p:cond evt="onClick" delay="0">
-                    <p:tgtEl>
-                      <p:spTgt spid="28"/>
-                    </p:tgtEl>
-                  </p:cond>
-                </p:stCondLst>
-                <p:endSync evt="end" delay="0">
-                  <p:rtn val="all"/>
-                </p:endSync>
-                <p:childTnLst>
-                  <p:par>
-                    <p:cTn id="56" fill="hold">
-                      <p:stCondLst>
-                        <p:cond delay="0"/>
-                      </p:stCondLst>
-                      <p:childTnLst>
-                        <p:par>
-                          <p:cTn id="57" presetID="10" presetClass="entr" presetSubtype="0" fill="hold" grpId="0" nodeType="clickEffect">
-                            <p:stCondLst>
-                              <p:cond delay="0"/>
-                            </p:stCondLst>
-                            <p:childTnLst>
-                              <p:set>
-                                <p:cBhvr>
-                                  <p:cTn id="58" dur="1" fill="hold">
-                                    <p:stCondLst>
-                                      <p:cond delay="0"/>
-                                    </p:stCondLst>
-                                  </p:cTn>
-                                  <p:tgtEl>
-                                    <p:spTgt spid="32"/>
-                                  </p:tgtEl>
-                                  <p:attrNameLst>
-                                    <p:attrName>style.visibility</p:attrName>
-                                  </p:attrNameLst>
-                                </p:cBhvr>
-                                <p:to>
-                                  <p:strVal val="visible"/>
-                                </p:to>
-                              </p:set>
-                              <p:animEffect transition="in" filter="fade">
-                                <p:cBhvr>
-                                  <p:cTn id="59" dur="400"/>
-                                  <p:tgtEl>
-                                    <p:spTgt spid="32"/>
-                                  </p:tgtEl>
-                                </p:cBhvr>
-                              </p:animEffect>
-                            </p:childTnLst>
-                          </p:cTn>
-                        </p:par>
-                      </p:childTnLst>
-                    </p:cTn>
-                  </p:par>
-                </p:childTnLst>
-              </p:cTn>
-              <p:nextCondLst>
-                <p:cond evt="onClick" delay="0">
-                  <p:tgtEl>
-                    <p:spTgt spid="28"/>
-                  </p:tgtEl>
-                </p:cond>
-              </p:nextCondLst>
-            </p:seq>
-            <p:seq concurrent="1" nextAc="seek">
-              <p:cTn id="65" restart="whenNotActive" fill="hold" nodeType="interactiveSeq">
-                <p:stCondLst>
-                  <p:cond evt="onClick" delay="0">
-                    <p:tgtEl>
-                      <p:spTgt spid="28"/>
-                    </p:tgtEl>
-                  </p:cond>
-                </p:stCondLst>
-                <p:endSync evt="end" delay="0">
-                  <p:rtn val="all"/>
-                </p:endSync>
-                <p:childTnLst>
-                  <p:par>
-                    <p:cTn id="66" fill="hold">
-                      <p:stCondLst>
-                        <p:cond delay="0"/>
-                      </p:stCondLst>
-                      <p:childTnLst>
-                        <p:par>
-                          <p:cTn id="67" presetID="10" presetClass="entr" presetSubtype="0" fill="hold" grpId="0" nodeType="clickEffect">
-                            <p:stCondLst>
-                              <p:cond delay="0"/>
-                            </p:stCondLst>
-                            <p:childTnLst>
-                              <p:set>
-                                <p:cBhvr>
-                                  <p:cTn id="68" dur="1" fill="hold">
-                                    <p:stCondLst>
-                                      <p:cond delay="0"/>
-                                    </p:stCondLst>
-                                  </p:cTn>
-                                  <p:tgtEl>
-                                    <p:spTgt spid="33"/>
-                                  </p:tgtEl>
-                                  <p:attrNameLst>
-                                    <p:attrName>style.visibility</p:attrName>
-                                  </p:attrNameLst>
-                                </p:cBhvr>
-                                <p:to>
-                                  <p:strVal val="visible"/>
-                                </p:to>
-                              </p:set>
-                              <p:animEffect transition="in" filter="fade">
-                                <p:cBhvr>
-                                  <p:cTn id="69" dur="400"/>
-                                  <p:tgtEl>
-                                    <p:spTgt spid="33"/>
-                                  </p:tgtEl>
-                                </p:cBhvr>
-                              </p:animEffect>
-                            </p:childTnLst>
-                          </p:cTn>
-                        </p:par>
-                      </p:childTnLst>
-                    </p:cTn>
-                  </p:par>
-                </p:childTnLst>
-              </p:cTn>
-              <p:nextCondLst>
-                <p:cond evt="onClick" delay="0">
-                  <p:tgtEl>
-                    <p:spTgt spid="28"/>
                   </p:tgtEl>
                 </p:cond>
               </p:nextCondLst>
@@ -31479,7 +31184,7 @@
                 </a:solidFill>
                 <a:latin typeface="Inter"/>
               </a:rPr>
-              <a:t>Leerlingenversie — kioskmodus</a:t>
+              <a:t>Leerlingenversie — klik onthult</a:t>
             </a:r>
           </a:p>
         </p:txBody>
@@ -33340,7 +33045,7 @@
                 </a:solidFill>
                 <a:latin typeface="Inter"/>
               </a:rPr>
-              <a:t>Leerlingenversie — kioskmodus</a:t>
+              <a:t>Leerlingenversie — klik onthult</a:t>
             </a:r>
           </a:p>
         </p:txBody>
@@ -35532,7 +35237,7 @@
                 </a:solidFill>
                 <a:latin typeface="Inter"/>
               </a:rPr>
-              <a:t>Leerlingenversie — kioskmodus</a:t>
+              <a:t>Leerlingenversie — klik onthult</a:t>
             </a:r>
           </a:p>
         </p:txBody>
@@ -40185,7 +39890,7 @@
                 </a:solidFill>
                 <a:latin typeface="Inter"/>
               </a:rPr>
-              <a:t>Leerlingenversie — kioskmodus</a:t>
+              <a:t>Leerlingenversie — klik onthult</a:t>
             </a:r>
           </a:p>
         </p:txBody>
@@ -42450,7 +42155,7 @@
                 </a:solidFill>
                 <a:latin typeface="Inter"/>
               </a:rPr>
-              <a:t>Leerlingenversie — kioskmodus</a:t>
+              <a:t>Leerlingenversie — klik onthult</a:t>
             </a:r>
           </a:p>
         </p:txBody>
@@ -45204,7 +44909,7 @@
                 </a:solidFill>
                 <a:latin typeface="Inter"/>
               </a:rPr>
-              <a:t>Leerlingenversie — kioskmodus</a:t>
+              <a:t>Leerlingenversie — klik onthult</a:t>
             </a:r>
           </a:p>
         </p:txBody>
@@ -45266,7 +44971,326 @@
           <p:childTnLst>
             <p:seq concurrent="1" nextAc="seek">
               <p:cTn id="2" dur="indefinite" nodeType="mainSeq">
-                <p:childTnLst/>
+                <p:childTnLst>
+                  <p:par>
+                    <p:cTn id="3" fill="hold">
+                      <p:stCondLst>
+                        <p:cond delay="indefinite"/>
+                      </p:stCondLst>
+                      <p:childTnLst>
+                        <p:par>
+                          <p:cTn id="4" fill="hold">
+                            <p:stCondLst>
+                              <p:cond delay="0"/>
+                            </p:stCondLst>
+                            <p:childTnLst>
+                              <p:par>
+                                <p:cTn id="5" presetID="10" presetClass="entr" presetSubtype="0" fill="hold" grpId="0" nodeType="clickEffect">
+                                  <p:stCondLst>
+                                    <p:cond delay="0"/>
+                                  </p:stCondLst>
+                                  <p:childTnLst>
+                                    <p:set>
+                                      <p:cBhvr>
+                                        <p:cTn id="6" dur="1" fill="hold">
+                                          <p:stCondLst>
+                                            <p:cond delay="0"/>
+                                          </p:stCondLst>
+                                        </p:cTn>
+                                        <p:tgtEl>
+                                          <p:spTgt spid="13"/>
+                                        </p:tgtEl>
+                                        <p:attrNameLst>
+                                          <p:attrName>style.visibility</p:attrName>
+                                        </p:attrNameLst>
+                                      </p:cBhvr>
+                                      <p:to>
+                                        <p:strVal val="visible"/>
+                                      </p:to>
+                                    </p:set>
+                                    <p:animEffect transition="in" filter="fade">
+                                      <p:cBhvr>
+                                        <p:cTn id="7" dur="500"/>
+                                        <p:tgtEl>
+                                          <p:spTgt spid="13"/>
+                                        </p:tgtEl>
+                                      </p:cBhvr>
+                                    </p:animEffect>
+                                  </p:childTnLst>
+                                </p:cTn>
+                              </p:par>
+                            </p:childTnLst>
+                          </p:cTn>
+                        </p:par>
+                      </p:childTnLst>
+                    </p:cTn>
+                  </p:par>
+                  <p:par>
+                    <p:cTn id="8" fill="hold">
+                      <p:stCondLst>
+                        <p:cond delay="indefinite"/>
+                      </p:stCondLst>
+                      <p:childTnLst>
+                        <p:par>
+                          <p:cTn id="9" fill="hold">
+                            <p:stCondLst>
+                              <p:cond delay="0"/>
+                            </p:stCondLst>
+                            <p:childTnLst>
+                              <p:par>
+                                <p:cTn id="10" presetID="10" presetClass="entr" presetSubtype="0" fill="hold" grpId="0" nodeType="clickEffect">
+                                  <p:stCondLst>
+                                    <p:cond delay="0"/>
+                                  </p:stCondLst>
+                                  <p:childTnLst>
+                                    <p:set>
+                                      <p:cBhvr>
+                                        <p:cTn id="11" dur="1" fill="hold">
+                                          <p:stCondLst>
+                                            <p:cond delay="0"/>
+                                          </p:stCondLst>
+                                        </p:cTn>
+                                        <p:tgtEl>
+                                          <p:spTgt spid="18"/>
+                                        </p:tgtEl>
+                                        <p:attrNameLst>
+                                          <p:attrName>style.visibility</p:attrName>
+                                        </p:attrNameLst>
+                                      </p:cBhvr>
+                                      <p:to>
+                                        <p:strVal val="visible"/>
+                                      </p:to>
+                                    </p:set>
+                                    <p:animEffect transition="in" filter="fade">
+                                      <p:cBhvr>
+                                        <p:cTn id="12" dur="500"/>
+                                        <p:tgtEl>
+                                          <p:spTgt spid="18"/>
+                                        </p:tgtEl>
+                                      </p:cBhvr>
+                                    </p:animEffect>
+                                  </p:childTnLst>
+                                </p:cTn>
+                              </p:par>
+                            </p:childTnLst>
+                          </p:cTn>
+                        </p:par>
+                      </p:childTnLst>
+                    </p:cTn>
+                  </p:par>
+                  <p:par>
+                    <p:cTn id="13" fill="hold">
+                      <p:stCondLst>
+                        <p:cond delay="indefinite"/>
+                      </p:stCondLst>
+                      <p:childTnLst>
+                        <p:par>
+                          <p:cTn id="14" fill="hold">
+                            <p:stCondLst>
+                              <p:cond delay="0"/>
+                            </p:stCondLst>
+                            <p:childTnLst>
+                              <p:par>
+                                <p:cTn id="15" presetID="10" presetClass="entr" presetSubtype="0" fill="hold" grpId="0" nodeType="clickEffect">
+                                  <p:stCondLst>
+                                    <p:cond delay="0"/>
+                                  </p:stCondLst>
+                                  <p:childTnLst>
+                                    <p:set>
+                                      <p:cBhvr>
+                                        <p:cTn id="16" dur="1" fill="hold">
+                                          <p:stCondLst>
+                                            <p:cond delay="0"/>
+                                          </p:stCondLst>
+                                        </p:cTn>
+                                        <p:tgtEl>
+                                          <p:spTgt spid="23"/>
+                                        </p:tgtEl>
+                                        <p:attrNameLst>
+                                          <p:attrName>style.visibility</p:attrName>
+                                        </p:attrNameLst>
+                                      </p:cBhvr>
+                                      <p:to>
+                                        <p:strVal val="visible"/>
+                                      </p:to>
+                                    </p:set>
+                                    <p:animEffect transition="in" filter="fade">
+                                      <p:cBhvr>
+                                        <p:cTn id="17" dur="500"/>
+                                        <p:tgtEl>
+                                          <p:spTgt spid="23"/>
+                                        </p:tgtEl>
+                                      </p:cBhvr>
+                                    </p:animEffect>
+                                  </p:childTnLst>
+                                </p:cTn>
+                              </p:par>
+                            </p:childTnLst>
+                          </p:cTn>
+                        </p:par>
+                      </p:childTnLst>
+                    </p:cTn>
+                  </p:par>
+                  <p:par>
+                    <p:cTn id="18" fill="hold">
+                      <p:stCondLst>
+                        <p:cond delay="indefinite"/>
+                      </p:stCondLst>
+                      <p:childTnLst>
+                        <p:par>
+                          <p:cTn id="19" fill="hold">
+                            <p:stCondLst>
+                              <p:cond delay="0"/>
+                            </p:stCondLst>
+                            <p:childTnLst>
+                              <p:par>
+                                <p:cTn id="20" presetID="10" presetClass="entr" presetSubtype="0" fill="hold" grpId="0" nodeType="clickEffect">
+                                  <p:stCondLst>
+                                    <p:cond delay="0"/>
+                                  </p:stCondLst>
+                                  <p:childTnLst>
+                                    <p:set>
+                                      <p:cBhvr>
+                                        <p:cTn id="21" dur="1" fill="hold">
+                                          <p:stCondLst>
+                                            <p:cond delay="0"/>
+                                          </p:stCondLst>
+                                        </p:cTn>
+                                        <p:tgtEl>
+                                          <p:spTgt spid="28"/>
+                                        </p:tgtEl>
+                                        <p:attrNameLst>
+                                          <p:attrName>style.visibility</p:attrName>
+                                        </p:attrNameLst>
+                                      </p:cBhvr>
+                                      <p:to>
+                                        <p:strVal val="visible"/>
+                                      </p:to>
+                                    </p:set>
+                                    <p:animEffect transition="in" filter="fade">
+                                      <p:cBhvr>
+                                        <p:cTn id="22" dur="500"/>
+                                        <p:tgtEl>
+                                          <p:spTgt spid="28"/>
+                                        </p:tgtEl>
+                                      </p:cBhvr>
+                                    </p:animEffect>
+                                  </p:childTnLst>
+                                </p:cTn>
+                              </p:par>
+                            </p:childTnLst>
+                          </p:cTn>
+                        </p:par>
+                      </p:childTnLst>
+                    </p:cTn>
+                  </p:par>
+                  <p:par>
+                    <p:cTn id="23" fill="hold">
+                      <p:stCondLst>
+                        <p:cond delay="indefinite"/>
+                      </p:stCondLst>
+                      <p:childTnLst>
+                        <p:par>
+                          <p:cTn id="24" fill="hold">
+                            <p:stCondLst>
+                              <p:cond delay="0"/>
+                            </p:stCondLst>
+                            <p:childTnLst>
+                              <p:par>
+                                <p:cTn id="25" presetID="10" presetClass="entr" presetSubtype="0" fill="hold" grpId="0" nodeType="clickEffect">
+                                  <p:stCondLst>
+                                    <p:cond delay="0"/>
+                                  </p:stCondLst>
+                                  <p:childTnLst>
+                                    <p:set>
+                                      <p:cBhvr>
+                                        <p:cTn id="26" dur="1" fill="hold">
+                                          <p:stCondLst>
+                                            <p:cond delay="0"/>
+                                          </p:stCondLst>
+                                        </p:cTn>
+                                        <p:tgtEl>
+                                          <p:spTgt spid="50"/>
+                                        </p:tgtEl>
+                                        <p:attrNameLst>
+                                          <p:attrName>style.visibility</p:attrName>
+                                        </p:attrNameLst>
+                                      </p:cBhvr>
+                                      <p:to>
+                                        <p:strVal val="visible"/>
+                                      </p:to>
+                                    </p:set>
+                                    <p:animEffect transition="in" filter="fade">
+                                      <p:cBhvr>
+                                        <p:cTn id="27" dur="500"/>
+                                        <p:tgtEl>
+                                          <p:spTgt spid="50"/>
+                                        </p:tgtEl>
+                                      </p:cBhvr>
+                                    </p:animEffect>
+                                  </p:childTnLst>
+                                </p:cTn>
+                              </p:par>
+                            </p:childTnLst>
+                          </p:cTn>
+                        </p:par>
+                      </p:childTnLst>
+                    </p:cTn>
+                  </p:par>
+                  <p:par>
+                    <p:cTn id="28" fill="hold">
+                      <p:stCondLst>
+                        <p:cond delay="indefinite"/>
+                      </p:stCondLst>
+                      <p:childTnLst>
+                        <p:par>
+                          <p:cTn id="29" fill="hold">
+                            <p:stCondLst>
+                              <p:cond delay="0"/>
+                            </p:stCondLst>
+                            <p:childTnLst>
+                              <p:par>
+                                <p:cTn id="30" presetID="10" presetClass="entr" presetSubtype="0" fill="hold" grpId="0" nodeType="clickEffect">
+                                  <p:stCondLst>
+                                    <p:cond delay="0"/>
+                                  </p:stCondLst>
+                                  <p:childTnLst>
+                                    <p:set>
+                                      <p:cBhvr>
+                                        <p:cTn id="31" dur="1" fill="hold">
+                                          <p:stCondLst>
+                                            <p:cond delay="0"/>
+                                          </p:stCondLst>
+                                        </p:cTn>
+                                        <p:tgtEl>
+                                          <p:spTgt spid="51"/>
+                                        </p:tgtEl>
+                                        <p:attrNameLst>
+                                          <p:attrName>style.visibility</p:attrName>
+                                        </p:attrNameLst>
+                                      </p:cBhvr>
+                                      <p:to>
+                                        <p:strVal val="visible"/>
+                                      </p:to>
+                                    </p:set>
+                                    <p:animEffect transition="in" filter="fade">
+                                      <p:cBhvr>
+                                        <p:cTn id="32" dur="500"/>
+                                        <p:tgtEl>
+                                          <p:spTgt spid="51"/>
+                                        </p:tgtEl>
+                                      </p:cBhvr>
+                                    </p:animEffect>
+                                  </p:childTnLst>
+                                </p:cTn>
+                              </p:par>
+                            </p:childTnLst>
+                          </p:cTn>
+                        </p:par>
+                      </p:childTnLst>
+                    </p:cTn>
+                  </p:par>
+                </p:childTnLst>
               </p:cTn>
               <p:prevCondLst>
                 <p:cond evt="onPrev" delay="0">
@@ -45279,408 +45303,6 @@
                 <p:cond evt="onNext" delay="0">
                   <p:tgtEl>
                     <p:sldTgt/>
-                  </p:tgtEl>
-                </p:cond>
-              </p:nextCondLst>
-            </p:seq>
-            <p:seq concurrent="1" nextAc="seek">
-              <p:cTn id="5" restart="whenNotActive" fill="hold" nodeType="interactiveSeq">
-                <p:stCondLst>
-                  <p:cond evt="onClick" delay="0">
-                    <p:tgtEl>
-                      <p:spTgt spid="11"/>
-                    </p:tgtEl>
-                  </p:cond>
-                </p:stCondLst>
-                <p:endSync evt="end" delay="0">
-                  <p:rtn val="all"/>
-                </p:endSync>
-                <p:childTnLst>
-                  <p:par>
-                    <p:cTn id="6" fill="hold">
-                      <p:stCondLst>
-                        <p:cond delay="0"/>
-                      </p:stCondLst>
-                      <p:childTnLst>
-                        <p:par>
-                          <p:cTn id="7" presetID="10" presetClass="entr" presetSubtype="0" fill="hold" grpId="0" nodeType="clickEffect">
-                            <p:stCondLst>
-                              <p:cond delay="0"/>
-                            </p:stCondLst>
-                            <p:childTnLst>
-                              <p:set>
-                                <p:cBhvr>
-                                  <p:cTn id="8" dur="1" fill="hold">
-                                    <p:stCondLst>
-                                      <p:cond delay="0"/>
-                                    </p:stCondLst>
-                                  </p:cTn>
-                                  <p:tgtEl>
-                                    <p:spTgt spid="13"/>
-                                  </p:tgtEl>
-                                  <p:attrNameLst>
-                                    <p:attrName>style.visibility</p:attrName>
-                                  </p:attrNameLst>
-                                </p:cBhvr>
-                                <p:to>
-                                  <p:strVal val="visible"/>
-                                </p:to>
-                              </p:set>
-                              <p:animEffect transition="in" filter="fade">
-                                <p:cBhvr>
-                                  <p:cTn id="9" dur="400"/>
-                                  <p:tgtEl>
-                                    <p:spTgt spid="13"/>
-                                  </p:tgtEl>
-                                </p:cBhvr>
-                              </p:animEffect>
-                            </p:childTnLst>
-                          </p:cTn>
-                        </p:par>
-                      </p:childTnLst>
-                    </p:cTn>
-                  </p:par>
-                </p:childTnLst>
-              </p:cTn>
-              <p:nextCondLst>
-                <p:cond evt="onClick" delay="0">
-                  <p:tgtEl>
-                    <p:spTgt spid="11"/>
-                  </p:tgtEl>
-                </p:cond>
-              </p:nextCondLst>
-            </p:seq>
-            <p:seq concurrent="1" nextAc="seek">
-              <p:cTn id="15" restart="whenNotActive" fill="hold" nodeType="interactiveSeq">
-                <p:stCondLst>
-                  <p:cond evt="onClick" delay="0">
-                    <p:tgtEl>
-                      <p:spTgt spid="16"/>
-                    </p:tgtEl>
-                  </p:cond>
-                </p:stCondLst>
-                <p:endSync evt="end" delay="0">
-                  <p:rtn val="all"/>
-                </p:endSync>
-                <p:childTnLst>
-                  <p:par>
-                    <p:cTn id="16" fill="hold">
-                      <p:stCondLst>
-                        <p:cond delay="0"/>
-                      </p:stCondLst>
-                      <p:childTnLst>
-                        <p:par>
-                          <p:cTn id="17" presetID="10" presetClass="entr" presetSubtype="0" fill="hold" grpId="0" nodeType="clickEffect">
-                            <p:stCondLst>
-                              <p:cond delay="0"/>
-                            </p:stCondLst>
-                            <p:childTnLst>
-                              <p:set>
-                                <p:cBhvr>
-                                  <p:cTn id="18" dur="1" fill="hold">
-                                    <p:stCondLst>
-                                      <p:cond delay="0"/>
-                                    </p:stCondLst>
-                                  </p:cTn>
-                                  <p:tgtEl>
-                                    <p:spTgt spid="18"/>
-                                  </p:tgtEl>
-                                  <p:attrNameLst>
-                                    <p:attrName>style.visibility</p:attrName>
-                                  </p:attrNameLst>
-                                </p:cBhvr>
-                                <p:to>
-                                  <p:strVal val="visible"/>
-                                </p:to>
-                              </p:set>
-                              <p:animEffect transition="in" filter="fade">
-                                <p:cBhvr>
-                                  <p:cTn id="19" dur="400"/>
-                                  <p:tgtEl>
-                                    <p:spTgt spid="18"/>
-                                  </p:tgtEl>
-                                </p:cBhvr>
-                              </p:animEffect>
-                            </p:childTnLst>
-                          </p:cTn>
-                        </p:par>
-                      </p:childTnLst>
-                    </p:cTn>
-                  </p:par>
-                </p:childTnLst>
-              </p:cTn>
-              <p:nextCondLst>
-                <p:cond evt="onClick" delay="0">
-                  <p:tgtEl>
-                    <p:spTgt spid="16"/>
-                  </p:tgtEl>
-                </p:cond>
-              </p:nextCondLst>
-            </p:seq>
-            <p:seq concurrent="1" nextAc="seek">
-              <p:cTn id="25" restart="whenNotActive" fill="hold" nodeType="interactiveSeq">
-                <p:stCondLst>
-                  <p:cond evt="onClick" delay="0">
-                    <p:tgtEl>
-                      <p:spTgt spid="21"/>
-                    </p:tgtEl>
-                  </p:cond>
-                </p:stCondLst>
-                <p:endSync evt="end" delay="0">
-                  <p:rtn val="all"/>
-                </p:endSync>
-                <p:childTnLst>
-                  <p:par>
-                    <p:cTn id="26" fill="hold">
-                      <p:stCondLst>
-                        <p:cond delay="0"/>
-                      </p:stCondLst>
-                      <p:childTnLst>
-                        <p:par>
-                          <p:cTn id="27" presetID="10" presetClass="entr" presetSubtype="0" fill="hold" grpId="0" nodeType="clickEffect">
-                            <p:stCondLst>
-                              <p:cond delay="0"/>
-                            </p:stCondLst>
-                            <p:childTnLst>
-                              <p:set>
-                                <p:cBhvr>
-                                  <p:cTn id="28" dur="1" fill="hold">
-                                    <p:stCondLst>
-                                      <p:cond delay="0"/>
-                                    </p:stCondLst>
-                                  </p:cTn>
-                                  <p:tgtEl>
-                                    <p:spTgt spid="23"/>
-                                  </p:tgtEl>
-                                  <p:attrNameLst>
-                                    <p:attrName>style.visibility</p:attrName>
-                                  </p:attrNameLst>
-                                </p:cBhvr>
-                                <p:to>
-                                  <p:strVal val="visible"/>
-                                </p:to>
-                              </p:set>
-                              <p:animEffect transition="in" filter="fade">
-                                <p:cBhvr>
-                                  <p:cTn id="29" dur="400"/>
-                                  <p:tgtEl>
-                                    <p:spTgt spid="23"/>
-                                  </p:tgtEl>
-                                </p:cBhvr>
-                              </p:animEffect>
-                            </p:childTnLst>
-                          </p:cTn>
-                        </p:par>
-                      </p:childTnLst>
-                    </p:cTn>
-                  </p:par>
-                </p:childTnLst>
-              </p:cTn>
-              <p:nextCondLst>
-                <p:cond evt="onClick" delay="0">
-                  <p:tgtEl>
-                    <p:spTgt spid="21"/>
-                  </p:tgtEl>
-                </p:cond>
-              </p:nextCondLst>
-            </p:seq>
-            <p:seq concurrent="1" nextAc="seek">
-              <p:cTn id="35" restart="whenNotActive" fill="hold" nodeType="interactiveSeq">
-                <p:stCondLst>
-                  <p:cond evt="onClick" delay="0">
-                    <p:tgtEl>
-                      <p:spTgt spid="26"/>
-                    </p:tgtEl>
-                  </p:cond>
-                </p:stCondLst>
-                <p:endSync evt="end" delay="0">
-                  <p:rtn val="all"/>
-                </p:endSync>
-                <p:childTnLst>
-                  <p:par>
-                    <p:cTn id="36" fill="hold">
-                      <p:stCondLst>
-                        <p:cond delay="0"/>
-                      </p:stCondLst>
-                      <p:childTnLst>
-                        <p:par>
-                          <p:cTn id="37" presetID="10" presetClass="entr" presetSubtype="0" fill="hold" grpId="0" nodeType="clickEffect">
-                            <p:stCondLst>
-                              <p:cond delay="0"/>
-                            </p:stCondLst>
-                            <p:childTnLst>
-                              <p:set>
-                                <p:cBhvr>
-                                  <p:cTn id="38" dur="1" fill="hold">
-                                    <p:stCondLst>
-                                      <p:cond delay="0"/>
-                                    </p:stCondLst>
-                                  </p:cTn>
-                                  <p:tgtEl>
-                                    <p:spTgt spid="28"/>
-                                  </p:tgtEl>
-                                  <p:attrNameLst>
-                                    <p:attrName>style.visibility</p:attrName>
-                                  </p:attrNameLst>
-                                </p:cBhvr>
-                                <p:to>
-                                  <p:strVal val="visible"/>
-                                </p:to>
-                              </p:set>
-                              <p:animEffect transition="in" filter="fade">
-                                <p:cBhvr>
-                                  <p:cTn id="39" dur="400"/>
-                                  <p:tgtEl>
-                                    <p:spTgt spid="28"/>
-                                  </p:tgtEl>
-                                </p:cBhvr>
-                              </p:animEffect>
-                            </p:childTnLst>
-                          </p:cTn>
-                        </p:par>
-                      </p:childTnLst>
-                    </p:cTn>
-                  </p:par>
-                </p:childTnLst>
-              </p:cTn>
-              <p:nextCondLst>
-                <p:cond evt="onClick" delay="0">
-                  <p:tgtEl>
-                    <p:spTgt spid="26"/>
-                  </p:tgtEl>
-                </p:cond>
-              </p:nextCondLst>
-            </p:seq>
-            <p:seq concurrent="1" nextAc="seek">
-              <p:cTn id="45" restart="whenNotActive" fill="hold" nodeType="interactiveSeq">
-                <p:stCondLst>
-                  <p:cond evt="onClick" delay="0">
-                    <p:tgtEl>
-                      <p:spTgt spid="46"/>
-                    </p:tgtEl>
-                  </p:cond>
-                </p:stCondLst>
-                <p:endSync evt="end" delay="0">
-                  <p:rtn val="all"/>
-                </p:endSync>
-                <p:childTnLst>
-                  <p:par>
-                    <p:cTn id="46" fill="hold">
-                      <p:stCondLst>
-                        <p:cond delay="0"/>
-                      </p:stCondLst>
-                      <p:childTnLst>
-                        <p:par>
-                          <p:cTn id="47" presetID="10" presetClass="entr" presetSubtype="0" fill="hold" grpId="0" nodeType="clickEffect">
-                            <p:stCondLst>
-                              <p:cond delay="0"/>
-                            </p:stCondLst>
-                            <p:childTnLst>
-                              <p:set>
-                                <p:cBhvr>
-                                  <p:cTn id="48" dur="1" fill="hold">
-                                    <p:stCondLst>
-                                      <p:cond delay="0"/>
-                                    </p:stCondLst>
-                                  </p:cTn>
-                                  <p:tgtEl>
-                                    <p:spTgt spid="50"/>
-                                  </p:tgtEl>
-                                  <p:attrNameLst>
-                                    <p:attrName>style.visibility</p:attrName>
-                                  </p:attrNameLst>
-                                </p:cBhvr>
-                                <p:to>
-                                  <p:strVal val="visible"/>
-                                </p:to>
-                              </p:set>
-                              <p:animEffect transition="in" filter="fade">
-                                <p:cBhvr>
-                                  <p:cTn id="49" dur="400"/>
-                                  <p:tgtEl>
-                                    <p:spTgt spid="50"/>
-                                  </p:tgtEl>
-                                </p:cBhvr>
-                              </p:animEffect>
-                            </p:childTnLst>
-                          </p:cTn>
-                        </p:par>
-                      </p:childTnLst>
-                    </p:cTn>
-                  </p:par>
-                </p:childTnLst>
-              </p:cTn>
-              <p:nextCondLst>
-                <p:cond evt="onClick" delay="0">
-                  <p:tgtEl>
-                    <p:spTgt spid="46"/>
-                  </p:tgtEl>
-                </p:cond>
-              </p:nextCondLst>
-            </p:seq>
-            <p:seq concurrent="1" nextAc="seek">
-              <p:cTn id="55" restart="whenNotActive" fill="hold" nodeType="interactiveSeq">
-                <p:stCondLst>
-                  <p:cond evt="onClick" delay="0">
-                    <p:tgtEl>
-                      <p:spTgt spid="46"/>
-                    </p:tgtEl>
-                  </p:cond>
-                </p:stCondLst>
-                <p:endSync evt="end" delay="0">
-                  <p:rtn val="all"/>
-                </p:endSync>
-                <p:childTnLst>
-                  <p:par>
-                    <p:cTn id="56" fill="hold">
-                      <p:stCondLst>
-                        <p:cond delay="0"/>
-                      </p:stCondLst>
-                      <p:childTnLst>
-                        <p:par>
-                          <p:cTn id="57" presetID="10" presetClass="entr" presetSubtype="0" fill="hold" grpId="0" nodeType="clickEffect">
-                            <p:stCondLst>
-                              <p:cond delay="0"/>
-                            </p:stCondLst>
-                            <p:childTnLst>
-                              <p:set>
-                                <p:cBhvr>
-                                  <p:cTn id="58" dur="1" fill="hold">
-                                    <p:stCondLst>
-                                      <p:cond delay="0"/>
-                                    </p:stCondLst>
-                                  </p:cTn>
-                                  <p:tgtEl>
-                                    <p:spTgt spid="51"/>
-                                  </p:tgtEl>
-                                  <p:attrNameLst>
-                                    <p:attrName>style.visibility</p:attrName>
-                                  </p:attrNameLst>
-                                </p:cBhvr>
-                                <p:to>
-                                  <p:strVal val="visible"/>
-                                </p:to>
-                              </p:set>
-                              <p:animEffect transition="in" filter="fade">
-                                <p:cBhvr>
-                                  <p:cTn id="59" dur="400"/>
-                                  <p:tgtEl>
-                                    <p:spTgt spid="51"/>
-                                  </p:tgtEl>
-                                </p:cBhvr>
-                              </p:animEffect>
-                            </p:childTnLst>
-                          </p:cTn>
-                        </p:par>
-                      </p:childTnLst>
-                    </p:cTn>
-                  </p:par>
-                </p:childTnLst>
-              </p:cTn>
-              <p:nextCondLst>
-                <p:cond evt="onClick" delay="0">
-                  <p:tgtEl>
-                    <p:spTgt spid="46"/>
                   </p:tgtEl>
                 </p:cond>
               </p:nextCondLst>
@@ -48175,7 +47797,7 @@
                 </a:solidFill>
                 <a:latin typeface="Inter"/>
               </a:rPr>
-              <a:t>Leerlingenversie — kioskmodus</a:t>
+              <a:t>Leerlingenversie — klik onthult</a:t>
             </a:r>
           </a:p>
         </p:txBody>
@@ -49956,7 +49578,7 @@
                 </a:solidFill>
                 <a:latin typeface="Inter"/>
               </a:rPr>
-              <a:t>Leerlingenversie — kioskmodus</a:t>
+              <a:t>Leerlingenversie — klik onthult</a:t>
             </a:r>
           </a:p>
         </p:txBody>
@@ -52630,7 +52252,7 @@
                 </a:solidFill>
                 <a:latin typeface="Inter"/>
               </a:rPr>
-              <a:t>Leerlingenversie — kioskmodus</a:t>
+              <a:t>Leerlingenversie — klik onthult</a:t>
             </a:r>
           </a:p>
         </p:txBody>
@@ -52692,7 +52314,538 @@
           <p:childTnLst>
             <p:seq concurrent="1" nextAc="seek">
               <p:cTn id="2" dur="indefinite" nodeType="mainSeq">
-                <p:childTnLst/>
+                <p:childTnLst>
+                  <p:par>
+                    <p:cTn id="3" fill="hold">
+                      <p:stCondLst>
+                        <p:cond delay="indefinite"/>
+                      </p:stCondLst>
+                      <p:childTnLst>
+                        <p:par>
+                          <p:cTn id="4" fill="hold">
+                            <p:stCondLst>
+                              <p:cond delay="0"/>
+                            </p:stCondLst>
+                            <p:childTnLst>
+                              <p:par>
+                                <p:cTn id="5" presetID="10" presetClass="entr" presetSubtype="0" fill="hold" grpId="0" nodeType="clickEffect">
+                                  <p:stCondLst>
+                                    <p:cond delay="0"/>
+                                  </p:stCondLst>
+                                  <p:childTnLst>
+                                    <p:set>
+                                      <p:cBhvr>
+                                        <p:cTn id="6" dur="1" fill="hold">
+                                          <p:stCondLst>
+                                            <p:cond delay="0"/>
+                                          </p:stCondLst>
+                                        </p:cTn>
+                                        <p:tgtEl>
+                                          <p:spTgt spid="11"/>
+                                        </p:tgtEl>
+                                        <p:attrNameLst>
+                                          <p:attrName>style.visibility</p:attrName>
+                                        </p:attrNameLst>
+                                      </p:cBhvr>
+                                      <p:to>
+                                        <p:strVal val="visible"/>
+                                      </p:to>
+                                    </p:set>
+                                    <p:animEffect transition="in" filter="fade">
+                                      <p:cBhvr>
+                                        <p:cTn id="7" dur="500"/>
+                                        <p:tgtEl>
+                                          <p:spTgt spid="11"/>
+                                        </p:tgtEl>
+                                      </p:cBhvr>
+                                    </p:animEffect>
+                                  </p:childTnLst>
+                                </p:cTn>
+                              </p:par>
+                            </p:childTnLst>
+                          </p:cTn>
+                        </p:par>
+                      </p:childTnLst>
+                    </p:cTn>
+                  </p:par>
+                  <p:par>
+                    <p:cTn id="8" fill="hold">
+                      <p:stCondLst>
+                        <p:cond delay="indefinite"/>
+                      </p:stCondLst>
+                      <p:childTnLst>
+                        <p:par>
+                          <p:cTn id="9" fill="hold">
+                            <p:stCondLst>
+                              <p:cond delay="0"/>
+                            </p:stCondLst>
+                            <p:childTnLst>
+                              <p:par>
+                                <p:cTn id="10" presetID="10" presetClass="entr" presetSubtype="0" fill="hold" grpId="0" nodeType="clickEffect">
+                                  <p:stCondLst>
+                                    <p:cond delay="0"/>
+                                  </p:stCondLst>
+                                  <p:childTnLst>
+                                    <p:set>
+                                      <p:cBhvr>
+                                        <p:cTn id="11" dur="1" fill="hold">
+                                          <p:stCondLst>
+                                            <p:cond delay="0"/>
+                                          </p:stCondLst>
+                                        </p:cTn>
+                                        <p:tgtEl>
+                                          <p:spTgt spid="15"/>
+                                        </p:tgtEl>
+                                        <p:attrNameLst>
+                                          <p:attrName>style.visibility</p:attrName>
+                                        </p:attrNameLst>
+                                      </p:cBhvr>
+                                      <p:to>
+                                        <p:strVal val="visible"/>
+                                      </p:to>
+                                    </p:set>
+                                    <p:animEffect transition="in" filter="fade">
+                                      <p:cBhvr>
+                                        <p:cTn id="12" dur="500"/>
+                                        <p:tgtEl>
+                                          <p:spTgt spid="15"/>
+                                        </p:tgtEl>
+                                      </p:cBhvr>
+                                    </p:animEffect>
+                                  </p:childTnLst>
+                                </p:cTn>
+                              </p:par>
+                            </p:childTnLst>
+                          </p:cTn>
+                        </p:par>
+                      </p:childTnLst>
+                    </p:cTn>
+                  </p:par>
+                  <p:par>
+                    <p:cTn id="13" fill="hold">
+                      <p:stCondLst>
+                        <p:cond delay="indefinite"/>
+                      </p:stCondLst>
+                      <p:childTnLst>
+                        <p:par>
+                          <p:cTn id="14" fill="hold">
+                            <p:stCondLst>
+                              <p:cond delay="0"/>
+                            </p:stCondLst>
+                            <p:childTnLst>
+                              <p:par>
+                                <p:cTn id="15" presetID="10" presetClass="entr" presetSubtype="0" fill="hold" grpId="0" nodeType="clickEffect">
+                                  <p:stCondLst>
+                                    <p:cond delay="0"/>
+                                  </p:stCondLst>
+                                  <p:childTnLst>
+                                    <p:set>
+                                      <p:cBhvr>
+                                        <p:cTn id="16" dur="1" fill="hold">
+                                          <p:stCondLst>
+                                            <p:cond delay="0"/>
+                                          </p:stCondLst>
+                                        </p:cTn>
+                                        <p:tgtEl>
+                                          <p:spTgt spid="19"/>
+                                        </p:tgtEl>
+                                        <p:attrNameLst>
+                                          <p:attrName>style.visibility</p:attrName>
+                                        </p:attrNameLst>
+                                      </p:cBhvr>
+                                      <p:to>
+                                        <p:strVal val="visible"/>
+                                      </p:to>
+                                    </p:set>
+                                    <p:animEffect transition="in" filter="fade">
+                                      <p:cBhvr>
+                                        <p:cTn id="17" dur="500"/>
+                                        <p:tgtEl>
+                                          <p:spTgt spid="19"/>
+                                        </p:tgtEl>
+                                      </p:cBhvr>
+                                    </p:animEffect>
+                                  </p:childTnLst>
+                                </p:cTn>
+                              </p:par>
+                            </p:childTnLst>
+                          </p:cTn>
+                        </p:par>
+                      </p:childTnLst>
+                    </p:cTn>
+                  </p:par>
+                  <p:par>
+                    <p:cTn id="18" fill="hold">
+                      <p:stCondLst>
+                        <p:cond delay="indefinite"/>
+                      </p:stCondLst>
+                      <p:childTnLst>
+                        <p:par>
+                          <p:cTn id="19" fill="hold">
+                            <p:stCondLst>
+                              <p:cond delay="0"/>
+                            </p:stCondLst>
+                            <p:childTnLst>
+                              <p:par>
+                                <p:cTn id="20" presetID="10" presetClass="entr" presetSubtype="0" fill="hold" grpId="0" nodeType="clickEffect">
+                                  <p:stCondLst>
+                                    <p:cond delay="0"/>
+                                  </p:stCondLst>
+                                  <p:childTnLst>
+                                    <p:set>
+                                      <p:cBhvr>
+                                        <p:cTn id="21" dur="1" fill="hold">
+                                          <p:stCondLst>
+                                            <p:cond delay="0"/>
+                                          </p:stCondLst>
+                                        </p:cTn>
+                                        <p:tgtEl>
+                                          <p:spTgt spid="23"/>
+                                        </p:tgtEl>
+                                        <p:attrNameLst>
+                                          <p:attrName>style.visibility</p:attrName>
+                                        </p:attrNameLst>
+                                      </p:cBhvr>
+                                      <p:to>
+                                        <p:strVal val="visible"/>
+                                      </p:to>
+                                    </p:set>
+                                    <p:animEffect transition="in" filter="fade">
+                                      <p:cBhvr>
+                                        <p:cTn id="22" dur="500"/>
+                                        <p:tgtEl>
+                                          <p:spTgt spid="23"/>
+                                        </p:tgtEl>
+                                      </p:cBhvr>
+                                    </p:animEffect>
+                                  </p:childTnLst>
+                                </p:cTn>
+                              </p:par>
+                            </p:childTnLst>
+                          </p:cTn>
+                        </p:par>
+                      </p:childTnLst>
+                    </p:cTn>
+                  </p:par>
+                  <p:par>
+                    <p:cTn id="23" fill="hold">
+                      <p:stCondLst>
+                        <p:cond delay="indefinite"/>
+                      </p:stCondLst>
+                      <p:childTnLst>
+                        <p:par>
+                          <p:cTn id="24" fill="hold">
+                            <p:stCondLst>
+                              <p:cond delay="0"/>
+                            </p:stCondLst>
+                            <p:childTnLst>
+                              <p:par>
+                                <p:cTn id="25" presetID="10" presetClass="entr" presetSubtype="0" fill="hold" grpId="0" nodeType="clickEffect">
+                                  <p:stCondLst>
+                                    <p:cond delay="0"/>
+                                  </p:stCondLst>
+                                  <p:childTnLst>
+                                    <p:set>
+                                      <p:cBhvr>
+                                        <p:cTn id="26" dur="1" fill="hold">
+                                          <p:stCondLst>
+                                            <p:cond delay="0"/>
+                                          </p:stCondLst>
+                                        </p:cTn>
+                                        <p:tgtEl>
+                                          <p:spTgt spid="27"/>
+                                        </p:tgtEl>
+                                        <p:attrNameLst>
+                                          <p:attrName>style.visibility</p:attrName>
+                                        </p:attrNameLst>
+                                      </p:cBhvr>
+                                      <p:to>
+                                        <p:strVal val="visible"/>
+                                      </p:to>
+                                    </p:set>
+                                    <p:animEffect transition="in" filter="fade">
+                                      <p:cBhvr>
+                                        <p:cTn id="27" dur="500"/>
+                                        <p:tgtEl>
+                                          <p:spTgt spid="27"/>
+                                        </p:tgtEl>
+                                      </p:cBhvr>
+                                    </p:animEffect>
+                                  </p:childTnLst>
+                                </p:cTn>
+                              </p:par>
+                            </p:childTnLst>
+                          </p:cTn>
+                        </p:par>
+                      </p:childTnLst>
+                    </p:cTn>
+                  </p:par>
+                  <p:par>
+                    <p:cTn id="28" fill="hold">
+                      <p:stCondLst>
+                        <p:cond delay="indefinite"/>
+                      </p:stCondLst>
+                      <p:childTnLst>
+                        <p:par>
+                          <p:cTn id="29" fill="hold">
+                            <p:stCondLst>
+                              <p:cond delay="0"/>
+                            </p:stCondLst>
+                            <p:childTnLst>
+                              <p:par>
+                                <p:cTn id="30" presetID="10" presetClass="entr" presetSubtype="0" fill="hold" grpId="0" nodeType="clickEffect">
+                                  <p:stCondLst>
+                                    <p:cond delay="0"/>
+                                  </p:stCondLst>
+                                  <p:childTnLst>
+                                    <p:set>
+                                      <p:cBhvr>
+                                        <p:cTn id="31" dur="1" fill="hold">
+                                          <p:stCondLst>
+                                            <p:cond delay="0"/>
+                                          </p:stCondLst>
+                                        </p:cTn>
+                                        <p:tgtEl>
+                                          <p:spTgt spid="31"/>
+                                        </p:tgtEl>
+                                        <p:attrNameLst>
+                                          <p:attrName>style.visibility</p:attrName>
+                                        </p:attrNameLst>
+                                      </p:cBhvr>
+                                      <p:to>
+                                        <p:strVal val="visible"/>
+                                      </p:to>
+                                    </p:set>
+                                    <p:animEffect transition="in" filter="fade">
+                                      <p:cBhvr>
+                                        <p:cTn id="32" dur="500"/>
+                                        <p:tgtEl>
+                                          <p:spTgt spid="31"/>
+                                        </p:tgtEl>
+                                      </p:cBhvr>
+                                    </p:animEffect>
+                                  </p:childTnLst>
+                                </p:cTn>
+                              </p:par>
+                            </p:childTnLst>
+                          </p:cTn>
+                        </p:par>
+                      </p:childTnLst>
+                    </p:cTn>
+                  </p:par>
+                  <p:par>
+                    <p:cTn id="33" fill="hold">
+                      <p:stCondLst>
+                        <p:cond delay="indefinite"/>
+                      </p:stCondLst>
+                      <p:childTnLst>
+                        <p:par>
+                          <p:cTn id="34" fill="hold">
+                            <p:stCondLst>
+                              <p:cond delay="0"/>
+                            </p:stCondLst>
+                            <p:childTnLst>
+                              <p:par>
+                                <p:cTn id="35" presetID="10" presetClass="entr" presetSubtype="0" fill="hold" grpId="0" nodeType="clickEffect">
+                                  <p:stCondLst>
+                                    <p:cond delay="0"/>
+                                  </p:stCondLst>
+                                  <p:childTnLst>
+                                    <p:set>
+                                      <p:cBhvr>
+                                        <p:cTn id="36" dur="1" fill="hold">
+                                          <p:stCondLst>
+                                            <p:cond delay="0"/>
+                                          </p:stCondLst>
+                                        </p:cTn>
+                                        <p:tgtEl>
+                                          <p:spTgt spid="35"/>
+                                        </p:tgtEl>
+                                        <p:attrNameLst>
+                                          <p:attrName>style.visibility</p:attrName>
+                                        </p:attrNameLst>
+                                      </p:cBhvr>
+                                      <p:to>
+                                        <p:strVal val="visible"/>
+                                      </p:to>
+                                    </p:set>
+                                    <p:animEffect transition="in" filter="fade">
+                                      <p:cBhvr>
+                                        <p:cTn id="37" dur="500"/>
+                                        <p:tgtEl>
+                                          <p:spTgt spid="35"/>
+                                        </p:tgtEl>
+                                      </p:cBhvr>
+                                    </p:animEffect>
+                                  </p:childTnLst>
+                                </p:cTn>
+                              </p:par>
+                            </p:childTnLst>
+                          </p:cTn>
+                        </p:par>
+                      </p:childTnLst>
+                    </p:cTn>
+                  </p:par>
+                  <p:par>
+                    <p:cTn id="38" fill="hold">
+                      <p:stCondLst>
+                        <p:cond delay="indefinite"/>
+                      </p:stCondLst>
+                      <p:childTnLst>
+                        <p:par>
+                          <p:cTn id="39" fill="hold">
+                            <p:stCondLst>
+                              <p:cond delay="0"/>
+                            </p:stCondLst>
+                            <p:childTnLst>
+                              <p:par>
+                                <p:cTn id="40" presetID="10" presetClass="entr" presetSubtype="0" fill="hold" grpId="0" nodeType="clickEffect">
+                                  <p:stCondLst>
+                                    <p:cond delay="0"/>
+                                  </p:stCondLst>
+                                  <p:childTnLst>
+                                    <p:set>
+                                      <p:cBhvr>
+                                        <p:cTn id="41" dur="1" fill="hold">
+                                          <p:stCondLst>
+                                            <p:cond delay="0"/>
+                                          </p:stCondLst>
+                                        </p:cTn>
+                                        <p:tgtEl>
+                                          <p:spTgt spid="39"/>
+                                        </p:tgtEl>
+                                        <p:attrNameLst>
+                                          <p:attrName>style.visibility</p:attrName>
+                                        </p:attrNameLst>
+                                      </p:cBhvr>
+                                      <p:to>
+                                        <p:strVal val="visible"/>
+                                      </p:to>
+                                    </p:set>
+                                    <p:animEffect transition="in" filter="fade">
+                                      <p:cBhvr>
+                                        <p:cTn id="42" dur="500"/>
+                                        <p:tgtEl>
+                                          <p:spTgt spid="39"/>
+                                        </p:tgtEl>
+                                      </p:cBhvr>
+                                    </p:animEffect>
+                                  </p:childTnLst>
+                                </p:cTn>
+                              </p:par>
+                            </p:childTnLst>
+                          </p:cTn>
+                        </p:par>
+                      </p:childTnLst>
+                    </p:cTn>
+                  </p:par>
+                  <p:par>
+                    <p:cTn id="43" fill="hold">
+                      <p:stCondLst>
+                        <p:cond delay="indefinite"/>
+                      </p:stCondLst>
+                      <p:childTnLst>
+                        <p:par>
+                          <p:cTn id="44" fill="hold">
+                            <p:stCondLst>
+                              <p:cond delay="0"/>
+                            </p:stCondLst>
+                            <p:childTnLst>
+                              <p:par>
+                                <p:cTn id="45" presetID="10" presetClass="entr" presetSubtype="0" fill="hold" grpId="0" nodeType="clickEffect">
+                                  <p:stCondLst>
+                                    <p:cond delay="0"/>
+                                  </p:stCondLst>
+                                  <p:childTnLst>
+                                    <p:set>
+                                      <p:cBhvr>
+                                        <p:cTn id="46" dur="1" fill="hold">
+                                          <p:stCondLst>
+                                            <p:cond delay="0"/>
+                                          </p:stCondLst>
+                                        </p:cTn>
+                                        <p:tgtEl>
+                                          <p:spTgt spid="44"/>
+                                        </p:tgtEl>
+                                        <p:attrNameLst>
+                                          <p:attrName>style.visibility</p:attrName>
+                                        </p:attrNameLst>
+                                      </p:cBhvr>
+                                      <p:to>
+                                        <p:strVal val="visible"/>
+                                      </p:to>
+                                    </p:set>
+                                    <p:animEffect transition="in" filter="fade">
+                                      <p:cBhvr>
+                                        <p:cTn id="47" dur="500"/>
+                                        <p:tgtEl>
+                                          <p:spTgt spid="44"/>
+                                        </p:tgtEl>
+                                      </p:cBhvr>
+                                    </p:animEffect>
+                                  </p:childTnLst>
+                                </p:cTn>
+                              </p:par>
+                            </p:childTnLst>
+                          </p:cTn>
+                        </p:par>
+                      </p:childTnLst>
+                    </p:cTn>
+                  </p:par>
+                  <p:par>
+                    <p:cTn id="48" fill="hold">
+                      <p:stCondLst>
+                        <p:cond delay="indefinite"/>
+                      </p:stCondLst>
+                      <p:childTnLst>
+                        <p:par>
+                          <p:cTn id="49" fill="hold">
+                            <p:stCondLst>
+                              <p:cond delay="0"/>
+                            </p:stCondLst>
+                            <p:childTnLst>
+                              <p:par>
+                                <p:cTn id="50" presetID="10" presetClass="entr" presetSubtype="0" fill="hold" grpId="0" nodeType="clickEffect">
+                                  <p:stCondLst>
+                                    <p:cond delay="0"/>
+                                  </p:stCondLst>
+                                  <p:childTnLst>
+                                    <p:set>
+                                      <p:cBhvr>
+                                        <p:cTn id="51" dur="1" fill="hold">
+                                          <p:stCondLst>
+                                            <p:cond delay="0"/>
+                                          </p:stCondLst>
+                                        </p:cTn>
+                                        <p:tgtEl>
+                                          <p:spTgt spid="45"/>
+                                        </p:tgtEl>
+                                        <p:attrNameLst>
+                                          <p:attrName>style.visibility</p:attrName>
+                                        </p:attrNameLst>
+                                      </p:cBhvr>
+                                      <p:to>
+                                        <p:strVal val="visible"/>
+                                      </p:to>
+                                    </p:set>
+                                    <p:animEffect transition="in" filter="fade">
+                                      <p:cBhvr>
+                                        <p:cTn id="52" dur="500"/>
+                                        <p:tgtEl>
+                                          <p:spTgt spid="45"/>
+                                        </p:tgtEl>
+                                      </p:cBhvr>
+                                    </p:animEffect>
+                                  </p:childTnLst>
+                                </p:cTn>
+                              </p:par>
+                            </p:childTnLst>
+                          </p:cTn>
+                        </p:par>
+                      </p:childTnLst>
+                    </p:cTn>
+                  </p:par>
+                </p:childTnLst>
               </p:cTn>
               <p:prevCondLst>
                 <p:cond evt="onPrev" delay="0">
@@ -52705,676 +52858,6 @@
                 <p:cond evt="onNext" delay="0">
                   <p:tgtEl>
                     <p:sldTgt/>
-                  </p:tgtEl>
-                </p:cond>
-              </p:nextCondLst>
-            </p:seq>
-            <p:seq concurrent="1" nextAc="seek">
-              <p:cTn id="5" restart="whenNotActive" fill="hold" nodeType="interactiveSeq">
-                <p:stCondLst>
-                  <p:cond evt="onClick" delay="0">
-                    <p:tgtEl>
-                      <p:spTgt spid="8"/>
-                    </p:tgtEl>
-                  </p:cond>
-                </p:stCondLst>
-                <p:endSync evt="end" delay="0">
-                  <p:rtn val="all"/>
-                </p:endSync>
-                <p:childTnLst>
-                  <p:par>
-                    <p:cTn id="6" fill="hold">
-                      <p:stCondLst>
-                        <p:cond delay="0"/>
-                      </p:stCondLst>
-                      <p:childTnLst>
-                        <p:par>
-                          <p:cTn id="7" presetID="10" presetClass="entr" presetSubtype="0" fill="hold" grpId="0" nodeType="clickEffect">
-                            <p:stCondLst>
-                              <p:cond delay="0"/>
-                            </p:stCondLst>
-                            <p:childTnLst>
-                              <p:set>
-                                <p:cBhvr>
-                                  <p:cTn id="8" dur="1" fill="hold">
-                                    <p:stCondLst>
-                                      <p:cond delay="0"/>
-                                    </p:stCondLst>
-                                  </p:cTn>
-                                  <p:tgtEl>
-                                    <p:spTgt spid="11"/>
-                                  </p:tgtEl>
-                                  <p:attrNameLst>
-                                    <p:attrName>style.visibility</p:attrName>
-                                  </p:attrNameLst>
-                                </p:cBhvr>
-                                <p:to>
-                                  <p:strVal val="visible"/>
-                                </p:to>
-                              </p:set>
-                              <p:animEffect transition="in" filter="fade">
-                                <p:cBhvr>
-                                  <p:cTn id="9" dur="400"/>
-                                  <p:tgtEl>
-                                    <p:spTgt spid="11"/>
-                                  </p:tgtEl>
-                                </p:cBhvr>
-                              </p:animEffect>
-                            </p:childTnLst>
-                          </p:cTn>
-                        </p:par>
-                      </p:childTnLst>
-                    </p:cTn>
-                  </p:par>
-                </p:childTnLst>
-              </p:cTn>
-              <p:nextCondLst>
-                <p:cond evt="onClick" delay="0">
-                  <p:tgtEl>
-                    <p:spTgt spid="8"/>
-                  </p:tgtEl>
-                </p:cond>
-              </p:nextCondLst>
-            </p:seq>
-            <p:seq concurrent="1" nextAc="seek">
-              <p:cTn id="15" restart="whenNotActive" fill="hold" nodeType="interactiveSeq">
-                <p:stCondLst>
-                  <p:cond evt="onClick" delay="0">
-                    <p:tgtEl>
-                      <p:spTgt spid="12"/>
-                    </p:tgtEl>
-                  </p:cond>
-                </p:stCondLst>
-                <p:endSync evt="end" delay="0">
-                  <p:rtn val="all"/>
-                </p:endSync>
-                <p:childTnLst>
-                  <p:par>
-                    <p:cTn id="16" fill="hold">
-                      <p:stCondLst>
-                        <p:cond delay="0"/>
-                      </p:stCondLst>
-                      <p:childTnLst>
-                        <p:par>
-                          <p:cTn id="17" presetID="10" presetClass="entr" presetSubtype="0" fill="hold" grpId="0" nodeType="clickEffect">
-                            <p:stCondLst>
-                              <p:cond delay="0"/>
-                            </p:stCondLst>
-                            <p:childTnLst>
-                              <p:set>
-                                <p:cBhvr>
-                                  <p:cTn id="18" dur="1" fill="hold">
-                                    <p:stCondLst>
-                                      <p:cond delay="0"/>
-                                    </p:stCondLst>
-                                  </p:cTn>
-                                  <p:tgtEl>
-                                    <p:spTgt spid="15"/>
-                                  </p:tgtEl>
-                                  <p:attrNameLst>
-                                    <p:attrName>style.visibility</p:attrName>
-                                  </p:attrNameLst>
-                                </p:cBhvr>
-                                <p:to>
-                                  <p:strVal val="visible"/>
-                                </p:to>
-                              </p:set>
-                              <p:animEffect transition="in" filter="fade">
-                                <p:cBhvr>
-                                  <p:cTn id="19" dur="400"/>
-                                  <p:tgtEl>
-                                    <p:spTgt spid="15"/>
-                                  </p:tgtEl>
-                                </p:cBhvr>
-                              </p:animEffect>
-                            </p:childTnLst>
-                          </p:cTn>
-                        </p:par>
-                      </p:childTnLst>
-                    </p:cTn>
-                  </p:par>
-                </p:childTnLst>
-              </p:cTn>
-              <p:nextCondLst>
-                <p:cond evt="onClick" delay="0">
-                  <p:tgtEl>
-                    <p:spTgt spid="12"/>
-                  </p:tgtEl>
-                </p:cond>
-              </p:nextCondLst>
-            </p:seq>
-            <p:seq concurrent="1" nextAc="seek">
-              <p:cTn id="25" restart="whenNotActive" fill="hold" nodeType="interactiveSeq">
-                <p:stCondLst>
-                  <p:cond evt="onClick" delay="0">
-                    <p:tgtEl>
-                      <p:spTgt spid="16"/>
-                    </p:tgtEl>
-                  </p:cond>
-                </p:stCondLst>
-                <p:endSync evt="end" delay="0">
-                  <p:rtn val="all"/>
-                </p:endSync>
-                <p:childTnLst>
-                  <p:par>
-                    <p:cTn id="26" fill="hold">
-                      <p:stCondLst>
-                        <p:cond delay="0"/>
-                      </p:stCondLst>
-                      <p:childTnLst>
-                        <p:par>
-                          <p:cTn id="27" presetID="10" presetClass="entr" presetSubtype="0" fill="hold" grpId="0" nodeType="clickEffect">
-                            <p:stCondLst>
-                              <p:cond delay="0"/>
-                            </p:stCondLst>
-                            <p:childTnLst>
-                              <p:set>
-                                <p:cBhvr>
-                                  <p:cTn id="28" dur="1" fill="hold">
-                                    <p:stCondLst>
-                                      <p:cond delay="0"/>
-                                    </p:stCondLst>
-                                  </p:cTn>
-                                  <p:tgtEl>
-                                    <p:spTgt spid="19"/>
-                                  </p:tgtEl>
-                                  <p:attrNameLst>
-                                    <p:attrName>style.visibility</p:attrName>
-                                  </p:attrNameLst>
-                                </p:cBhvr>
-                                <p:to>
-                                  <p:strVal val="visible"/>
-                                </p:to>
-                              </p:set>
-                              <p:animEffect transition="in" filter="fade">
-                                <p:cBhvr>
-                                  <p:cTn id="29" dur="400"/>
-                                  <p:tgtEl>
-                                    <p:spTgt spid="19"/>
-                                  </p:tgtEl>
-                                </p:cBhvr>
-                              </p:animEffect>
-                            </p:childTnLst>
-                          </p:cTn>
-                        </p:par>
-                      </p:childTnLst>
-                    </p:cTn>
-                  </p:par>
-                </p:childTnLst>
-              </p:cTn>
-              <p:nextCondLst>
-                <p:cond evt="onClick" delay="0">
-                  <p:tgtEl>
-                    <p:spTgt spid="16"/>
-                  </p:tgtEl>
-                </p:cond>
-              </p:nextCondLst>
-            </p:seq>
-            <p:seq concurrent="1" nextAc="seek">
-              <p:cTn id="35" restart="whenNotActive" fill="hold" nodeType="interactiveSeq">
-                <p:stCondLst>
-                  <p:cond evt="onClick" delay="0">
-                    <p:tgtEl>
-                      <p:spTgt spid="20"/>
-                    </p:tgtEl>
-                  </p:cond>
-                </p:stCondLst>
-                <p:endSync evt="end" delay="0">
-                  <p:rtn val="all"/>
-                </p:endSync>
-                <p:childTnLst>
-                  <p:par>
-                    <p:cTn id="36" fill="hold">
-                      <p:stCondLst>
-                        <p:cond delay="0"/>
-                      </p:stCondLst>
-                      <p:childTnLst>
-                        <p:par>
-                          <p:cTn id="37" presetID="10" presetClass="entr" presetSubtype="0" fill="hold" grpId="0" nodeType="clickEffect">
-                            <p:stCondLst>
-                              <p:cond delay="0"/>
-                            </p:stCondLst>
-                            <p:childTnLst>
-                              <p:set>
-                                <p:cBhvr>
-                                  <p:cTn id="38" dur="1" fill="hold">
-                                    <p:stCondLst>
-                                      <p:cond delay="0"/>
-                                    </p:stCondLst>
-                                  </p:cTn>
-                                  <p:tgtEl>
-                                    <p:spTgt spid="23"/>
-                                  </p:tgtEl>
-                                  <p:attrNameLst>
-                                    <p:attrName>style.visibility</p:attrName>
-                                  </p:attrNameLst>
-                                </p:cBhvr>
-                                <p:to>
-                                  <p:strVal val="visible"/>
-                                </p:to>
-                              </p:set>
-                              <p:animEffect transition="in" filter="fade">
-                                <p:cBhvr>
-                                  <p:cTn id="39" dur="400"/>
-                                  <p:tgtEl>
-                                    <p:spTgt spid="23"/>
-                                  </p:tgtEl>
-                                </p:cBhvr>
-                              </p:animEffect>
-                            </p:childTnLst>
-                          </p:cTn>
-                        </p:par>
-                      </p:childTnLst>
-                    </p:cTn>
-                  </p:par>
-                </p:childTnLst>
-              </p:cTn>
-              <p:nextCondLst>
-                <p:cond evt="onClick" delay="0">
-                  <p:tgtEl>
-                    <p:spTgt spid="20"/>
-                  </p:tgtEl>
-                </p:cond>
-              </p:nextCondLst>
-            </p:seq>
-            <p:seq concurrent="1" nextAc="seek">
-              <p:cTn id="45" restart="whenNotActive" fill="hold" nodeType="interactiveSeq">
-                <p:stCondLst>
-                  <p:cond evt="onClick" delay="0">
-                    <p:tgtEl>
-                      <p:spTgt spid="24"/>
-                    </p:tgtEl>
-                  </p:cond>
-                </p:stCondLst>
-                <p:endSync evt="end" delay="0">
-                  <p:rtn val="all"/>
-                </p:endSync>
-                <p:childTnLst>
-                  <p:par>
-                    <p:cTn id="46" fill="hold">
-                      <p:stCondLst>
-                        <p:cond delay="0"/>
-                      </p:stCondLst>
-                      <p:childTnLst>
-                        <p:par>
-                          <p:cTn id="47" presetID="10" presetClass="entr" presetSubtype="0" fill="hold" grpId="0" nodeType="clickEffect">
-                            <p:stCondLst>
-                              <p:cond delay="0"/>
-                            </p:stCondLst>
-                            <p:childTnLst>
-                              <p:set>
-                                <p:cBhvr>
-                                  <p:cTn id="48" dur="1" fill="hold">
-                                    <p:stCondLst>
-                                      <p:cond delay="0"/>
-                                    </p:stCondLst>
-                                  </p:cTn>
-                                  <p:tgtEl>
-                                    <p:spTgt spid="27"/>
-                                  </p:tgtEl>
-                                  <p:attrNameLst>
-                                    <p:attrName>style.visibility</p:attrName>
-                                  </p:attrNameLst>
-                                </p:cBhvr>
-                                <p:to>
-                                  <p:strVal val="visible"/>
-                                </p:to>
-                              </p:set>
-                              <p:animEffect transition="in" filter="fade">
-                                <p:cBhvr>
-                                  <p:cTn id="49" dur="400"/>
-                                  <p:tgtEl>
-                                    <p:spTgt spid="27"/>
-                                  </p:tgtEl>
-                                </p:cBhvr>
-                              </p:animEffect>
-                            </p:childTnLst>
-                          </p:cTn>
-                        </p:par>
-                      </p:childTnLst>
-                    </p:cTn>
-                  </p:par>
-                </p:childTnLst>
-              </p:cTn>
-              <p:nextCondLst>
-                <p:cond evt="onClick" delay="0">
-                  <p:tgtEl>
-                    <p:spTgt spid="24"/>
-                  </p:tgtEl>
-                </p:cond>
-              </p:nextCondLst>
-            </p:seq>
-            <p:seq concurrent="1" nextAc="seek">
-              <p:cTn id="55" restart="whenNotActive" fill="hold" nodeType="interactiveSeq">
-                <p:stCondLst>
-                  <p:cond evt="onClick" delay="0">
-                    <p:tgtEl>
-                      <p:spTgt spid="28"/>
-                    </p:tgtEl>
-                  </p:cond>
-                </p:stCondLst>
-                <p:endSync evt="end" delay="0">
-                  <p:rtn val="all"/>
-                </p:endSync>
-                <p:childTnLst>
-                  <p:par>
-                    <p:cTn id="56" fill="hold">
-                      <p:stCondLst>
-                        <p:cond delay="0"/>
-                      </p:stCondLst>
-                      <p:childTnLst>
-                        <p:par>
-                          <p:cTn id="57" presetID="10" presetClass="entr" presetSubtype="0" fill="hold" grpId="0" nodeType="clickEffect">
-                            <p:stCondLst>
-                              <p:cond delay="0"/>
-                            </p:stCondLst>
-                            <p:childTnLst>
-                              <p:set>
-                                <p:cBhvr>
-                                  <p:cTn id="58" dur="1" fill="hold">
-                                    <p:stCondLst>
-                                      <p:cond delay="0"/>
-                                    </p:stCondLst>
-                                  </p:cTn>
-                                  <p:tgtEl>
-                                    <p:spTgt spid="31"/>
-                                  </p:tgtEl>
-                                  <p:attrNameLst>
-                                    <p:attrName>style.visibility</p:attrName>
-                                  </p:attrNameLst>
-                                </p:cBhvr>
-                                <p:to>
-                                  <p:strVal val="visible"/>
-                                </p:to>
-                              </p:set>
-                              <p:animEffect transition="in" filter="fade">
-                                <p:cBhvr>
-                                  <p:cTn id="59" dur="400"/>
-                                  <p:tgtEl>
-                                    <p:spTgt spid="31"/>
-                                  </p:tgtEl>
-                                </p:cBhvr>
-                              </p:animEffect>
-                            </p:childTnLst>
-                          </p:cTn>
-                        </p:par>
-                      </p:childTnLst>
-                    </p:cTn>
-                  </p:par>
-                </p:childTnLst>
-              </p:cTn>
-              <p:nextCondLst>
-                <p:cond evt="onClick" delay="0">
-                  <p:tgtEl>
-                    <p:spTgt spid="28"/>
-                  </p:tgtEl>
-                </p:cond>
-              </p:nextCondLst>
-            </p:seq>
-            <p:seq concurrent="1" nextAc="seek">
-              <p:cTn id="65" restart="whenNotActive" fill="hold" nodeType="interactiveSeq">
-                <p:stCondLst>
-                  <p:cond evt="onClick" delay="0">
-                    <p:tgtEl>
-                      <p:spTgt spid="32"/>
-                    </p:tgtEl>
-                  </p:cond>
-                </p:stCondLst>
-                <p:endSync evt="end" delay="0">
-                  <p:rtn val="all"/>
-                </p:endSync>
-                <p:childTnLst>
-                  <p:par>
-                    <p:cTn id="66" fill="hold">
-                      <p:stCondLst>
-                        <p:cond delay="0"/>
-                      </p:stCondLst>
-                      <p:childTnLst>
-                        <p:par>
-                          <p:cTn id="67" presetID="10" presetClass="entr" presetSubtype="0" fill="hold" grpId="0" nodeType="clickEffect">
-                            <p:stCondLst>
-                              <p:cond delay="0"/>
-                            </p:stCondLst>
-                            <p:childTnLst>
-                              <p:set>
-                                <p:cBhvr>
-                                  <p:cTn id="68" dur="1" fill="hold">
-                                    <p:stCondLst>
-                                      <p:cond delay="0"/>
-                                    </p:stCondLst>
-                                  </p:cTn>
-                                  <p:tgtEl>
-                                    <p:spTgt spid="35"/>
-                                  </p:tgtEl>
-                                  <p:attrNameLst>
-                                    <p:attrName>style.visibility</p:attrName>
-                                  </p:attrNameLst>
-                                </p:cBhvr>
-                                <p:to>
-                                  <p:strVal val="visible"/>
-                                </p:to>
-                              </p:set>
-                              <p:animEffect transition="in" filter="fade">
-                                <p:cBhvr>
-                                  <p:cTn id="69" dur="400"/>
-                                  <p:tgtEl>
-                                    <p:spTgt spid="35"/>
-                                  </p:tgtEl>
-                                </p:cBhvr>
-                              </p:animEffect>
-                            </p:childTnLst>
-                          </p:cTn>
-                        </p:par>
-                      </p:childTnLst>
-                    </p:cTn>
-                  </p:par>
-                </p:childTnLst>
-              </p:cTn>
-              <p:nextCondLst>
-                <p:cond evt="onClick" delay="0">
-                  <p:tgtEl>
-                    <p:spTgt spid="32"/>
-                  </p:tgtEl>
-                </p:cond>
-              </p:nextCondLst>
-            </p:seq>
-            <p:seq concurrent="1" nextAc="seek">
-              <p:cTn id="75" restart="whenNotActive" fill="hold" nodeType="interactiveSeq">
-                <p:stCondLst>
-                  <p:cond evt="onClick" delay="0">
-                    <p:tgtEl>
-                      <p:spTgt spid="36"/>
-                    </p:tgtEl>
-                  </p:cond>
-                </p:stCondLst>
-                <p:endSync evt="end" delay="0">
-                  <p:rtn val="all"/>
-                </p:endSync>
-                <p:childTnLst>
-                  <p:par>
-                    <p:cTn id="76" fill="hold">
-                      <p:stCondLst>
-                        <p:cond delay="0"/>
-                      </p:stCondLst>
-                      <p:childTnLst>
-                        <p:par>
-                          <p:cTn id="77" presetID="10" presetClass="entr" presetSubtype="0" fill="hold" grpId="0" nodeType="clickEffect">
-                            <p:stCondLst>
-                              <p:cond delay="0"/>
-                            </p:stCondLst>
-                            <p:childTnLst>
-                              <p:set>
-                                <p:cBhvr>
-                                  <p:cTn id="78" dur="1" fill="hold">
-                                    <p:stCondLst>
-                                      <p:cond delay="0"/>
-                                    </p:stCondLst>
-                                  </p:cTn>
-                                  <p:tgtEl>
-                                    <p:spTgt spid="39"/>
-                                  </p:tgtEl>
-                                  <p:attrNameLst>
-                                    <p:attrName>style.visibility</p:attrName>
-                                  </p:attrNameLst>
-                                </p:cBhvr>
-                                <p:to>
-                                  <p:strVal val="visible"/>
-                                </p:to>
-                              </p:set>
-                              <p:animEffect transition="in" filter="fade">
-                                <p:cBhvr>
-                                  <p:cTn id="79" dur="400"/>
-                                  <p:tgtEl>
-                                    <p:spTgt spid="39"/>
-                                  </p:tgtEl>
-                                </p:cBhvr>
-                              </p:animEffect>
-                            </p:childTnLst>
-                          </p:cTn>
-                        </p:par>
-                      </p:childTnLst>
-                    </p:cTn>
-                  </p:par>
-                </p:childTnLst>
-              </p:cTn>
-              <p:nextCondLst>
-                <p:cond evt="onClick" delay="0">
-                  <p:tgtEl>
-                    <p:spTgt spid="36"/>
-                  </p:tgtEl>
-                </p:cond>
-              </p:nextCondLst>
-            </p:seq>
-            <p:seq concurrent="1" nextAc="seek">
-              <p:cTn id="85" restart="whenNotActive" fill="hold" nodeType="interactiveSeq">
-                <p:stCondLst>
-                  <p:cond evt="onClick" delay="0">
-                    <p:tgtEl>
-                      <p:spTgt spid="40"/>
-                    </p:tgtEl>
-                  </p:cond>
-                </p:stCondLst>
-                <p:endSync evt="end" delay="0">
-                  <p:rtn val="all"/>
-                </p:endSync>
-                <p:childTnLst>
-                  <p:par>
-                    <p:cTn id="86" fill="hold">
-                      <p:stCondLst>
-                        <p:cond delay="0"/>
-                      </p:stCondLst>
-                      <p:childTnLst>
-                        <p:par>
-                          <p:cTn id="87" presetID="10" presetClass="entr" presetSubtype="0" fill="hold" grpId="0" nodeType="clickEffect">
-                            <p:stCondLst>
-                              <p:cond delay="0"/>
-                            </p:stCondLst>
-                            <p:childTnLst>
-                              <p:set>
-                                <p:cBhvr>
-                                  <p:cTn id="88" dur="1" fill="hold">
-                                    <p:stCondLst>
-                                      <p:cond delay="0"/>
-                                    </p:stCondLst>
-                                  </p:cTn>
-                                  <p:tgtEl>
-                                    <p:spTgt spid="44"/>
-                                  </p:tgtEl>
-                                  <p:attrNameLst>
-                                    <p:attrName>style.visibility</p:attrName>
-                                  </p:attrNameLst>
-                                </p:cBhvr>
-                                <p:to>
-                                  <p:strVal val="visible"/>
-                                </p:to>
-                              </p:set>
-                              <p:animEffect transition="in" filter="fade">
-                                <p:cBhvr>
-                                  <p:cTn id="89" dur="400"/>
-                                  <p:tgtEl>
-                                    <p:spTgt spid="44"/>
-                                  </p:tgtEl>
-                                </p:cBhvr>
-                              </p:animEffect>
-                            </p:childTnLst>
-                          </p:cTn>
-                        </p:par>
-                      </p:childTnLst>
-                    </p:cTn>
-                  </p:par>
-                </p:childTnLst>
-              </p:cTn>
-              <p:nextCondLst>
-                <p:cond evt="onClick" delay="0">
-                  <p:tgtEl>
-                    <p:spTgt spid="40"/>
-                  </p:tgtEl>
-                </p:cond>
-              </p:nextCondLst>
-            </p:seq>
-            <p:seq concurrent="1" nextAc="seek">
-              <p:cTn id="95" restart="whenNotActive" fill="hold" nodeType="interactiveSeq">
-                <p:stCondLst>
-                  <p:cond evt="onClick" delay="0">
-                    <p:tgtEl>
-                      <p:spTgt spid="40"/>
-                    </p:tgtEl>
-                  </p:cond>
-                </p:stCondLst>
-                <p:endSync evt="end" delay="0">
-                  <p:rtn val="all"/>
-                </p:endSync>
-                <p:childTnLst>
-                  <p:par>
-                    <p:cTn id="96" fill="hold">
-                      <p:stCondLst>
-                        <p:cond delay="0"/>
-                      </p:stCondLst>
-                      <p:childTnLst>
-                        <p:par>
-                          <p:cTn id="97" presetID="10" presetClass="entr" presetSubtype="0" fill="hold" grpId="0" nodeType="clickEffect">
-                            <p:stCondLst>
-                              <p:cond delay="0"/>
-                            </p:stCondLst>
-                            <p:childTnLst>
-                              <p:set>
-                                <p:cBhvr>
-                                  <p:cTn id="98" dur="1" fill="hold">
-                                    <p:stCondLst>
-                                      <p:cond delay="0"/>
-                                    </p:stCondLst>
-                                  </p:cTn>
-                                  <p:tgtEl>
-                                    <p:spTgt spid="45"/>
-                                  </p:tgtEl>
-                                  <p:attrNameLst>
-                                    <p:attrName>style.visibility</p:attrName>
-                                  </p:attrNameLst>
-                                </p:cBhvr>
-                                <p:to>
-                                  <p:strVal val="visible"/>
-                                </p:to>
-                              </p:set>
-                              <p:animEffect transition="in" filter="fade">
-                                <p:cBhvr>
-                                  <p:cTn id="99" dur="400"/>
-                                  <p:tgtEl>
-                                    <p:spTgt spid="45"/>
-                                  </p:tgtEl>
-                                </p:cBhvr>
-                              </p:animEffect>
-                            </p:childTnLst>
-                          </p:cTn>
-                        </p:par>
-                      </p:childTnLst>
-                    </p:cTn>
-                  </p:par>
-                </p:childTnLst>
-              </p:cTn>
-              <p:nextCondLst>
-                <p:cond evt="onClick" delay="0">
-                  <p:tgtEl>
-                    <p:spTgt spid="40"/>
                   </p:tgtEl>
                 </p:cond>
               </p:nextCondLst>

</xml_diff>

<commit_message>
U0-U4 PDF + PowerPoint → U5-model (ultracode-workflow, option A + verificatie). PDF: traditioneel×modern-oefenbatterij + Lectura + tarea comunicativa/sectie + kruisverwijzingen naar de verrijkte hubs; parels in de print (U2 Rosalía-árbol + primo/sobrino-valstrik · U4 Banda sonora met uitgebreide bio's + «La Perla»-gustar-schaal). PowerPoint: 4 vaardigheden + kruisverwijzingen, alumno als .pptx (stale .ppsx U0/U1 verwijderd). Alle 5 units PASS in adversariële verificatie: geen lege pagina's, beide pptx openen. Stale game-tellingen rechtgezet naar 20 (was 24/18/14) in print+pptx over U1-U5. U0 golden sample minimaal (kruisverwijzingen+hygiëne)
</commit_message>
<xml_diff>
--- a/03-build/pptx/C5_U0_alumno.pptx
+++ b/03-build/pptx/C5_U0_alumno.pptx
@@ -20412,17 +20412,164 @@
       </p:sp>
       <p:sp>
         <p:nvSpPr>
-          <p:cNvPr id="67" name="Rectangle 66"/>
+          <p:cNvPr id="67" name="Rounded Rectangle 66"/>
           <p:cNvSpPr/>
           <p:nvPr/>
         </p:nvSpPr>
         <p:spPr>
           <a:xfrm>
-            <a:off x="0" y="6547104"/>
-            <a:ext cx="12191695" cy="310896"/>
-          </a:xfrm>
-          <a:prstGeom prst="rect">
-            <a:avLst/>
+            <a:off x="457200" y="5559552"/>
+            <a:ext cx="2474366" cy="292608"/>
+          </a:xfrm>
+          <a:prstGeom prst="roundRect">
+            <a:avLst>
+              <a:gd name="adj" fmla="val 50000"/>
+            </a:avLst>
+          </a:prstGeom>
+          <a:solidFill>
+            <a:srgbClr val="E4F4EE"/>
+          </a:solidFill>
+          <a:ln>
+            <a:noFill/>
+          </a:ln>
+          <a:effectLst/>
+        </p:spPr>
+        <p:style>
+          <a:lnRef idx="1">
+            <a:schemeClr val="accent1"/>
+          </a:lnRef>
+          <a:fillRef idx="3">
+            <a:schemeClr val="accent1"/>
+          </a:fillRef>
+          <a:effectRef idx="2">
+            <a:schemeClr val="accent1"/>
+          </a:effectRef>
+          <a:fontRef idx="minor">
+            <a:schemeClr val="lt1"/>
+          </a:fontRef>
+        </p:style>
+        <p:txBody>
+          <a:bodyPr rtlCol="0" anchor="ctr" wrap="none" lIns="88900" rIns="88900" tIns="12700" bIns="12700"/>
+          <a:lstStyle/>
+          <a:p>
+            <a:pPr algn="ctr"/>
+            <a:r>
+              <a:rPr sz="1050" b="1">
+                <a:solidFill>
+                  <a:srgbClr val="157355"/>
+                </a:solidFill>
+                <a:latin typeface="Inter"/>
+              </a:rPr>
+              <a:t>👀 LEER · comprensión lectora</a:t>
+            </a:r>
+          </a:p>
+        </p:txBody>
+      </p:sp>
+      <p:sp>
+        <p:nvSpPr>
+          <p:cNvPr id="68" name="TextBox 67"/>
+          <p:cNvSpPr txBox="1"/>
+          <p:nvPr/>
+        </p:nvSpPr>
+        <p:spPr>
+          <a:xfrm>
+            <a:off x="457200" y="5943600"/>
+            <a:ext cx="7315200" cy="457200"/>
+          </a:xfrm>
+          <a:prstGeom prst="rect">
+            <a:avLst/>
+          </a:prstGeom>
+          <a:noFill/>
+        </p:spPr>
+        <p:txBody>
+          <a:bodyPr wrap="square" anchor="t" lIns="38100" rIns="38100" tIns="25400" bIns="25400">
+            <a:spAutoFit/>
+          </a:bodyPr>
+          <a:lstStyle/>
+          <a:p>
+            <a:pPr algn="l">
+              <a:lnSpc>
+                <a:spcPct val="106000"/>
+              </a:lnSpc>
+              <a:spcBef>
+                <a:spcPts val="0"/>
+              </a:spcBef>
+              <a:spcAft>
+                <a:spcPts val="200"/>
+              </a:spcAft>
+            </a:pPr>
+            <a:r>
+              <a:rPr sz="1100" b="0" i="0">
+                <a:solidFill>
+                  <a:srgbClr val="20242E"/>
+                </a:solidFill>
+                <a:latin typeface="Inter"/>
+              </a:rPr>
+              <a:t>V/F · Lee la lista: «En Brasil se habla español.»  </a:t>
+            </a:r>
+          </a:p>
+        </p:txBody>
+      </p:sp>
+      <p:sp>
+        <p:nvSpPr>
+          <p:cNvPr id="69" name="TextBox 68"/>
+          <p:cNvSpPr txBox="1"/>
+          <p:nvPr/>
+        </p:nvSpPr>
+        <p:spPr>
+          <a:xfrm>
+            <a:off x="5669280" y="5943600"/>
+            <a:ext cx="1920240" cy="457200"/>
+          </a:xfrm>
+          <a:prstGeom prst="rect">
+            <a:avLst/>
+          </a:prstGeom>
+          <a:noFill/>
+        </p:spPr>
+        <p:txBody>
+          <a:bodyPr wrap="square" anchor="ctr" lIns="38100" rIns="38100" tIns="25400" bIns="25400">
+            <a:spAutoFit/>
+          </a:bodyPr>
+          <a:lstStyle/>
+          <a:p>
+            <a:pPr algn="l">
+              <a:lnSpc>
+                <a:spcPct val="106000"/>
+              </a:lnSpc>
+              <a:spcBef>
+                <a:spcPts val="0"/>
+              </a:spcBef>
+              <a:spcAft>
+                <a:spcPts val="200"/>
+              </a:spcAft>
+            </a:pPr>
+            <a:r>
+              <a:rPr sz="1100" b="1" i="0">
+                <a:solidFill>
+                  <a:srgbClr val="DC2626"/>
+                </a:solidFill>
+                <a:latin typeface="Inter"/>
+              </a:rPr>
+              <a:t>→ FALSO (portugués)</a:t>
+            </a:r>
+          </a:p>
+        </p:txBody>
+      </p:sp>
+      <p:sp>
+        <p:nvSpPr>
+          <p:cNvPr id="70" name="Rounded Rectangle 69"/>
+          <p:cNvSpPr/>
+          <p:nvPr/>
+        </p:nvSpPr>
+        <p:spPr>
+          <a:xfrm>
+            <a:off x="7772400" y="5943600"/>
+            <a:ext cx="3147364" cy="292608"/>
+          </a:xfrm>
+          <a:prstGeom prst="roundRect">
+            <a:avLst>
+              <a:gd name="adj" fmla="val 50000"/>
+            </a:avLst>
           </a:prstGeom>
           <a:solidFill>
             <a:srgbClr val="F3EEE4"/>
@@ -20447,6 +20594,59 @@
           </a:fontRef>
         </p:style>
         <p:txBody>
+          <a:bodyPr rtlCol="0" anchor="ctr" wrap="none" lIns="88900" rIns="88900" tIns="12700" bIns="12700"/>
+          <a:lstStyle/>
+          <a:p>
+            <a:pPr algn="ctr"/>
+            <a:r>
+              <a:rPr sz="1000" b="1">
+                <a:solidFill>
+                  <a:srgbClr val="157355"/>
+                </a:solidFill>
+                <a:latin typeface="Inter"/>
+              </a:rPr>
+              <a:t>🔗 Online: mapa clicable + flip cards</a:t>
+            </a:r>
+          </a:p>
+        </p:txBody>
+      </p:sp>
+      <p:sp>
+        <p:nvSpPr>
+          <p:cNvPr id="71" name="Rectangle 70"/>
+          <p:cNvSpPr/>
+          <p:nvPr/>
+        </p:nvSpPr>
+        <p:spPr>
+          <a:xfrm>
+            <a:off x="0" y="6547104"/>
+            <a:ext cx="12191695" cy="310896"/>
+          </a:xfrm>
+          <a:prstGeom prst="rect">
+            <a:avLst/>
+          </a:prstGeom>
+          <a:solidFill>
+            <a:srgbClr val="F3EEE4"/>
+          </a:solidFill>
+          <a:ln>
+            <a:noFill/>
+          </a:ln>
+          <a:effectLst/>
+        </p:spPr>
+        <p:style>
+          <a:lnRef idx="1">
+            <a:schemeClr val="accent1"/>
+          </a:lnRef>
+          <a:fillRef idx="3">
+            <a:schemeClr val="accent1"/>
+          </a:fillRef>
+          <a:effectRef idx="2">
+            <a:schemeClr val="accent1"/>
+          </a:effectRef>
+          <a:fontRef idx="minor">
+            <a:schemeClr val="lt1"/>
+          </a:fontRef>
+        </p:style>
+        <p:txBody>
           <a:bodyPr rtlCol="0" anchor="ctr"/>
           <a:lstStyle/>
           <a:p>
@@ -20456,7 +20656,7 @@
       </p:sp>
       <p:sp>
         <p:nvSpPr>
-          <p:cNvPr id="68" name="TextBox 67"/>
+          <p:cNvPr id="72" name="TextBox 71"/>
           <p:cNvSpPr txBox="1"/>
           <p:nvPr/>
         </p:nvSpPr>
@@ -20510,7 +20710,7 @@
       </p:sp>
       <p:sp>
         <p:nvSpPr>
-          <p:cNvPr id="69" name="TextBox 68"/>
+          <p:cNvPr id="73" name="TextBox 72"/>
           <p:cNvSpPr txBox="1"/>
           <p:nvPr/>
         </p:nvSpPr>
@@ -20555,7 +20755,7 @@
       </p:sp>
       <p:sp>
         <p:nvSpPr>
-          <p:cNvPr id="70" name="TextBox 69"/>
+          <p:cNvPr id="74" name="TextBox 73"/>
           <p:cNvSpPr txBox="1"/>
           <p:nvPr/>
         </p:nvSpPr>
@@ -20603,6 +20803,89 @@
   <p:clrMapOvr>
     <a:masterClrMapping/>
   </p:clrMapOvr>
+  <p:timing>
+    <p:tnLst>
+      <p:par>
+        <p:cTn id="1" dur="indefinite" restart="never" nodeType="tmRoot">
+          <p:childTnLst>
+            <p:seq concurrent="1" nextAc="seek">
+              <p:cTn id="2" dur="indefinite" nodeType="mainSeq">
+                <p:childTnLst>
+                  <p:par>
+                    <p:cTn id="3" fill="hold">
+                      <p:stCondLst>
+                        <p:cond delay="indefinite"/>
+                      </p:stCondLst>
+                      <p:childTnLst>
+                        <p:par>
+                          <p:cTn id="4" fill="hold">
+                            <p:stCondLst>
+                              <p:cond delay="0"/>
+                            </p:stCondLst>
+                            <p:childTnLst>
+                              <p:par>
+                                <p:cTn id="5" presetID="10" presetClass="entr" presetSubtype="0" fill="hold" grpId="0" nodeType="clickEffect">
+                                  <p:stCondLst>
+                                    <p:cond delay="0"/>
+                                  </p:stCondLst>
+                                  <p:childTnLst>
+                                    <p:set>
+                                      <p:cBhvr>
+                                        <p:cTn id="6" dur="1" fill="hold">
+                                          <p:stCondLst>
+                                            <p:cond delay="0"/>
+                                          </p:stCondLst>
+                                        </p:cTn>
+                                        <p:tgtEl>
+                                          <p:spTgt spid="69"/>
+                                        </p:tgtEl>
+                                        <p:attrNameLst>
+                                          <p:attrName>style.visibility</p:attrName>
+                                        </p:attrNameLst>
+                                      </p:cBhvr>
+                                      <p:to>
+                                        <p:strVal val="visible"/>
+                                      </p:to>
+                                    </p:set>
+                                    <p:animEffect transition="in" filter="fade">
+                                      <p:cBhvr>
+                                        <p:cTn id="7" dur="500"/>
+                                        <p:tgtEl>
+                                          <p:spTgt spid="69"/>
+                                        </p:tgtEl>
+                                      </p:cBhvr>
+                                    </p:animEffect>
+                                  </p:childTnLst>
+                                </p:cTn>
+                              </p:par>
+                            </p:childTnLst>
+                          </p:cTn>
+                        </p:par>
+                      </p:childTnLst>
+                    </p:cTn>
+                  </p:par>
+                </p:childTnLst>
+              </p:cTn>
+              <p:prevCondLst>
+                <p:cond evt="onPrev" delay="0">
+                  <p:tgtEl>
+                    <p:sldTgt/>
+                  </p:tgtEl>
+                </p:cond>
+              </p:prevCondLst>
+              <p:nextCondLst>
+                <p:cond evt="onNext" delay="0">
+                  <p:tgtEl>
+                    <p:sldTgt/>
+                  </p:tgtEl>
+                </p:cond>
+              </p:nextCondLst>
+            </p:seq>
+          </p:childTnLst>
+        </p:cTn>
+      </p:par>
+    </p:tnLst>
+  </p:timing>
 </p:sld>
 </file>
 

</xml_diff>